<commit_message>
Die letzten Commits vor der Abgabe
</commit_message>
<xml_diff>
--- a/Simulationen_und_Dokumentationen/Dokumentationen/Präsentation-Jahresprojekt.pptx
+++ b/Simulationen_und_Dokumentationen/Dokumentationen/Präsentation-Jahresprojekt.pptx
@@ -5,17 +5,30 @@
     <p:sldMasterId id="2147483693" r:id="rId1"/>
   </p:sldMasterIdLst>
   <p:notesMasterIdLst>
-    <p:notesMasterId r:id="rId10"/>
+    <p:notesMasterId r:id="rId23"/>
   </p:notesMasterIdLst>
   <p:sldIdLst>
     <p:sldId id="256" r:id="rId2"/>
     <p:sldId id="276" r:id="rId3"/>
-    <p:sldId id="274" r:id="rId4"/>
+    <p:sldId id="281" r:id="rId4"/>
     <p:sldId id="275" r:id="rId5"/>
-    <p:sldId id="278" r:id="rId6"/>
-    <p:sldId id="280" r:id="rId7"/>
-    <p:sldId id="279" r:id="rId8"/>
-    <p:sldId id="271" r:id="rId9"/>
+    <p:sldId id="289" r:id="rId6"/>
+    <p:sldId id="282" r:id="rId7"/>
+    <p:sldId id="290" r:id="rId8"/>
+    <p:sldId id="291" r:id="rId9"/>
+    <p:sldId id="287" r:id="rId10"/>
+    <p:sldId id="293" r:id="rId11"/>
+    <p:sldId id="295" r:id="rId12"/>
+    <p:sldId id="294" r:id="rId13"/>
+    <p:sldId id="296" r:id="rId14"/>
+    <p:sldId id="297" r:id="rId15"/>
+    <p:sldId id="298" r:id="rId16"/>
+    <p:sldId id="288" r:id="rId17"/>
+    <p:sldId id="292" r:id="rId18"/>
+    <p:sldId id="284" r:id="rId19"/>
+    <p:sldId id="285" r:id="rId20"/>
+    <p:sldId id="286" r:id="rId21"/>
+    <p:sldId id="271" r:id="rId22"/>
   </p:sldIdLst>
   <p:sldSz cx="20104100" cy="11258550"/>
   <p:notesSz cx="20104100" cy="11258550"/>
@@ -117,7 +130,7 @@
           <a:p>
             <a:fld id="{9B32CCA1-4475-43BB-8E25-41D5FBD7FEC8}" type="datetimeFigureOut">
               <a:rPr lang="de-AT" smtClean="0"/>
-              <a:t>03.03.2026</a:t>
+              <a:t>05.03.2026</a:t>
             </a:fld>
             <a:endParaRPr lang="de-AT" dirty="0"/>
           </a:p>
@@ -9689,7 +9702,7 @@
           <a:p>
             <a:fld id="{1D8BD707-D9CF-40AE-B4C6-C98DA3205C09}" type="datetimeFigureOut">
               <a:rPr lang="en-US"/>
-              <a:t>3/3/2026</a:t>
+              <a:t>3/5/2026</a:t>
             </a:fld>
             <a:endParaRPr lang="en-US" dirty="0"/>
           </a:p>
@@ -9957,7 +9970,7 @@
           <a:p>
             <a:fld id="{1D8BD707-D9CF-40AE-B4C6-C98DA3205C09}" type="datetimeFigureOut">
               <a:rPr lang="en-US"/>
-              <a:t>3/3/2026</a:t>
+              <a:t>3/5/2026</a:t>
             </a:fld>
             <a:endParaRPr lang="en-US" dirty="0"/>
           </a:p>
@@ -10732,7 +10745,7 @@
           <a:p>
             <a:fld id="{1D8BD707-D9CF-40AE-B4C6-C98DA3205C09}" type="datetimeFigureOut">
               <a:rPr lang="en-US"/>
-              <a:t>3/3/2026</a:t>
+              <a:t>3/5/2026</a:t>
             </a:fld>
             <a:endParaRPr lang="en-US" dirty="0"/>
           </a:p>
@@ -12482,7 +12495,7 @@
           <a:p>
             <a:fld id="{1D8BD707-D9CF-40AE-B4C6-C98DA3205C09}" type="datetimeFigureOut">
               <a:rPr lang="en-US"/>
-              <a:t>3/3/2026</a:t>
+              <a:t>3/5/2026</a:t>
             </a:fld>
             <a:endParaRPr lang="en-US" dirty="0"/>
           </a:p>
@@ -13908,7 +13921,7 @@
           <a:p>
             <a:fld id="{1D8BD707-D9CF-40AE-B4C6-C98DA3205C09}" type="datetimeFigureOut">
               <a:rPr lang="en-US"/>
-              <a:t>3/3/2026</a:t>
+              <a:t>3/5/2026</a:t>
             </a:fld>
             <a:endParaRPr lang="en-US" dirty="0"/>
           </a:p>
@@ -16378,7 +16391,7 @@
           <a:p>
             <a:fld id="{1D8BD707-D9CF-40AE-B4C6-C98DA3205C09}" type="datetimeFigureOut">
               <a:rPr lang="en-US"/>
-              <a:t>3/3/2026</a:t>
+              <a:t>3/5/2026</a:t>
             </a:fld>
             <a:endParaRPr lang="en-US" dirty="0"/>
           </a:p>
@@ -22196,7 +22209,7 @@
           <a:p>
             <a:fld id="{1D8BD707-D9CF-40AE-B4C6-C98DA3205C09}" type="datetimeFigureOut">
               <a:rPr lang="en-US"/>
-              <a:t>3/3/2026</a:t>
+              <a:t>3/5/2026</a:t>
             </a:fld>
             <a:endParaRPr lang="en-US" dirty="0"/>
           </a:p>
@@ -22618,7 +22631,7 @@
           <a:p>
             <a:fld id="{1D8BD707-D9CF-40AE-B4C6-C98DA3205C09}" type="datetimeFigureOut">
               <a:rPr lang="en-US"/>
-              <a:t>3/3/2026</a:t>
+              <a:t>3/5/2026</a:t>
             </a:fld>
             <a:endParaRPr lang="en-US" dirty="0"/>
           </a:p>
@@ -23011,7 +23024,7 @@
           <a:p>
             <a:fld id="{1D8BD707-D9CF-40AE-B4C6-C98DA3205C09}" type="datetimeFigureOut">
               <a:rPr lang="en-US"/>
-              <a:t>3/3/2026</a:t>
+              <a:t>3/5/2026</a:t>
             </a:fld>
             <a:endParaRPr lang="en-US" dirty="0"/>
           </a:p>
@@ -23529,7 +23542,7 @@
           <a:p>
             <a:fld id="{1D8BD707-D9CF-40AE-B4C6-C98DA3205C09}" type="datetimeFigureOut">
               <a:rPr lang="en-US"/>
-              <a:t>3/3/2026</a:t>
+              <a:t>3/5/2026</a:t>
             </a:fld>
             <a:endParaRPr lang="en-US" dirty="0"/>
           </a:p>
@@ -23899,7 +23912,7 @@
           <a:p>
             <a:fld id="{1D8BD707-D9CF-40AE-B4C6-C98DA3205C09}" type="datetimeFigureOut">
               <a:rPr lang="en-US"/>
-              <a:t>3/3/2026</a:t>
+              <a:t>3/5/2026</a:t>
             </a:fld>
             <a:endParaRPr lang="en-US" dirty="0"/>
           </a:p>
@@ -24076,7 +24089,7 @@
           <a:p>
             <a:fld id="{1D8BD707-D9CF-40AE-B4C6-C98DA3205C09}" type="datetimeFigureOut">
               <a:rPr lang="en-US"/>
-              <a:t>3/3/2026</a:t>
+              <a:t>3/5/2026</a:t>
             </a:fld>
             <a:endParaRPr lang="en-US" dirty="0"/>
           </a:p>
@@ -24319,7 +24332,7 @@
           <a:p>
             <a:fld id="{1D8BD707-D9CF-40AE-B4C6-C98DA3205C09}" type="datetimeFigureOut">
               <a:rPr lang="en-US"/>
-              <a:t>3/3/2026</a:t>
+              <a:t>3/5/2026</a:t>
             </a:fld>
             <a:endParaRPr lang="en-US" dirty="0"/>
           </a:p>
@@ -24483,7 +24496,7 @@
           <a:p>
             <a:fld id="{1D8BD707-D9CF-40AE-B4C6-C98DA3205C09}" type="datetimeFigureOut">
               <a:rPr lang="en-US"/>
-              <a:t>3/3/2026</a:t>
+              <a:t>3/5/2026</a:t>
             </a:fld>
             <a:endParaRPr lang="en-US"/>
           </a:p>
@@ -29432,6 +29445,2390 @@
 </p:sld>
 </file>
 
+<file path=ppt/slides/slide10.xml><?xml version="1.0" encoding="utf-8"?>
+<p:sld xmlns:a="http://schemas.openxmlformats.org/drawingml/2006/main" xmlns:r="http://schemas.openxmlformats.org/officeDocument/2006/relationships" xmlns:p="http://schemas.openxmlformats.org/presentationml/2006/main">
+  <p:cSld>
+    <p:spTree>
+      <p:nvGrpSpPr>
+        <p:cNvPr id="1" name="">
+          <a:extLst>
+            <a:ext uri="{FF2B5EF4-FFF2-40B4-BE49-F238E27FC236}">
+              <a16:creationId xmlns:a16="http://schemas.microsoft.com/office/drawing/2014/main" id="{CC2E7DB2-F7B1-7BF1-0D7B-2941137A23A0}"/>
+            </a:ext>
+          </a:extLst>
+        </p:cNvPr>
+        <p:cNvGrpSpPr/>
+        <p:nvPr/>
+      </p:nvGrpSpPr>
+      <p:grpSpPr>
+        <a:xfrm>
+          <a:off x="0" y="0"/>
+          <a:ext cx="0" cy="0"/>
+          <a:chOff x="0" y="0"/>
+          <a:chExt cx="0" cy="0"/>
+        </a:xfrm>
+      </p:grpSpPr>
+      <p:sp>
+        <p:nvSpPr>
+          <p:cNvPr id="2" name="Textplatzhalter 1">
+            <a:extLst>
+              <a:ext uri="{FF2B5EF4-FFF2-40B4-BE49-F238E27FC236}">
+                <a16:creationId xmlns:a16="http://schemas.microsoft.com/office/drawing/2014/main" id="{4AFE4DCE-F842-74A0-C865-1527DF20CBD2}"/>
+              </a:ext>
+            </a:extLst>
+          </p:cNvPr>
+          <p:cNvSpPr>
+            <a:spLocks noGrp="1"/>
+          </p:cNvSpPr>
+          <p:nvPr>
+            <p:ph type="body" idx="1"/>
+          </p:nvPr>
+        </p:nvSpPr>
+        <p:spPr/>
+        <p:txBody>
+          <a:bodyPr/>
+          <a:lstStyle/>
+          <a:p>
+            <a:r>
+              <a:rPr lang="de-DE" b="1" dirty="0"/>
+              <a:t>Manuel</a:t>
+            </a:r>
+          </a:p>
+          <a:p>
+            <a:pPr marL="457200" indent="-457200">
+              <a:buFont typeface="Arial" panose="020B0604020202020204" pitchFamily="34" charset="0"/>
+              <a:buChar char="•"/>
+            </a:pPr>
+            <a:r>
+              <a:rPr lang="de-DE" sz="3200" dirty="0"/>
+              <a:t>Bildübertragung auf LED-Matrix</a:t>
+            </a:r>
+          </a:p>
+          <a:p>
+            <a:pPr marL="457200" indent="-457200">
+              <a:buFont typeface="Arial" panose="020B0604020202020204" pitchFamily="34" charset="0"/>
+              <a:buChar char="•"/>
+            </a:pPr>
+            <a:r>
+              <a:rPr lang="de-DE" sz="3200" dirty="0"/>
+              <a:t>Case und Platinen Designe </a:t>
+            </a:r>
+          </a:p>
+          <a:p>
+            <a:pPr marL="457200" indent="-457200">
+              <a:buFont typeface="Arial" panose="020B0604020202020204" pitchFamily="34" charset="0"/>
+              <a:buChar char="•"/>
+            </a:pPr>
+            <a:r>
+              <a:rPr lang="de-DE" sz="3200" dirty="0"/>
+              <a:t>Case Fertigung</a:t>
+            </a:r>
+          </a:p>
+          <a:p>
+            <a:pPr marL="457200" indent="-457200">
+              <a:buFont typeface="Arial" panose="020B0604020202020204" pitchFamily="34" charset="0"/>
+              <a:buChar char="•"/>
+            </a:pPr>
+            <a:r>
+              <a:rPr lang="de-DE" sz="3200" dirty="0"/>
+              <a:t>Dokumentation und </a:t>
+            </a:r>
+            <a:r>
+              <a:rPr lang="de-DE" sz="3200" dirty="0" err="1"/>
+              <a:t>Github</a:t>
+            </a:r>
+            <a:r>
+              <a:rPr lang="de-DE" sz="3200" dirty="0"/>
+              <a:t> Verwaltung</a:t>
+            </a:r>
+          </a:p>
+        </p:txBody>
+      </p:sp>
+      <p:sp>
+        <p:nvSpPr>
+          <p:cNvPr id="4" name="Titel 3">
+            <a:extLst>
+              <a:ext uri="{FF2B5EF4-FFF2-40B4-BE49-F238E27FC236}">
+                <a16:creationId xmlns:a16="http://schemas.microsoft.com/office/drawing/2014/main" id="{FB011655-2943-A858-7F43-18DC27D543EB}"/>
+              </a:ext>
+            </a:extLst>
+          </p:cNvPr>
+          <p:cNvSpPr>
+            <a:spLocks noGrp="1"/>
+          </p:cNvSpPr>
+          <p:nvPr>
+            <p:ph type="title"/>
+          </p:nvPr>
+        </p:nvSpPr>
+        <p:spPr/>
+        <p:txBody>
+          <a:bodyPr/>
+          <a:lstStyle/>
+          <a:p>
+            <a:r>
+              <a:rPr lang="de-DE" dirty="0"/>
+              <a:t>Manuel</a:t>
+            </a:r>
+          </a:p>
+        </p:txBody>
+      </p:sp>
+      <p:sp>
+        <p:nvSpPr>
+          <p:cNvPr id="6" name="Textplatzhalter 5">
+            <a:extLst>
+              <a:ext uri="{FF2B5EF4-FFF2-40B4-BE49-F238E27FC236}">
+                <a16:creationId xmlns:a16="http://schemas.microsoft.com/office/drawing/2014/main" id="{858E66CC-3F3B-A67C-89AB-B1B885F849F5}"/>
+              </a:ext>
+            </a:extLst>
+          </p:cNvPr>
+          <p:cNvSpPr>
+            <a:spLocks noGrp="1"/>
+          </p:cNvSpPr>
+          <p:nvPr>
+            <p:ph type="body" idx="10"/>
+          </p:nvPr>
+        </p:nvSpPr>
+        <p:spPr/>
+        <p:txBody>
+          <a:bodyPr/>
+          <a:lstStyle/>
+          <a:p>
+            <a:endParaRPr lang="de-AT" dirty="0"/>
+          </a:p>
+        </p:txBody>
+      </p:sp>
+    </p:spTree>
+    <p:extLst>
+      <p:ext uri="{BB962C8B-B14F-4D97-AF65-F5344CB8AC3E}">
+        <p14:creationId xmlns:p14="http://schemas.microsoft.com/office/powerpoint/2010/main" val="3230412208"/>
+      </p:ext>
+    </p:extLst>
+  </p:cSld>
+  <p:clrMapOvr>
+    <a:masterClrMapping/>
+  </p:clrMapOvr>
+</p:sld>
+</file>
+
+<file path=ppt/slides/slide11.xml><?xml version="1.0" encoding="utf-8"?>
+<p:sld xmlns:a="http://schemas.openxmlformats.org/drawingml/2006/main" xmlns:r="http://schemas.openxmlformats.org/officeDocument/2006/relationships" xmlns:p="http://schemas.openxmlformats.org/presentationml/2006/main">
+  <p:cSld>
+    <p:spTree>
+      <p:nvGrpSpPr>
+        <p:cNvPr id="1" name="">
+          <a:extLst>
+            <a:ext uri="{FF2B5EF4-FFF2-40B4-BE49-F238E27FC236}">
+              <a16:creationId xmlns:a16="http://schemas.microsoft.com/office/drawing/2014/main" id="{5EE128F7-77D5-E9C2-61C2-99E01B1FC181}"/>
+            </a:ext>
+          </a:extLst>
+        </p:cNvPr>
+        <p:cNvGrpSpPr/>
+        <p:nvPr/>
+      </p:nvGrpSpPr>
+      <p:grpSpPr>
+        <a:xfrm>
+          <a:off x="0" y="0"/>
+          <a:ext cx="0" cy="0"/>
+          <a:chOff x="0" y="0"/>
+          <a:chExt cx="0" cy="0"/>
+        </a:xfrm>
+      </p:grpSpPr>
+      <p:sp>
+        <p:nvSpPr>
+          <p:cNvPr id="3" name="Textplatzhalter 2">
+            <a:extLst>
+              <a:ext uri="{FF2B5EF4-FFF2-40B4-BE49-F238E27FC236}">
+                <a16:creationId xmlns:a16="http://schemas.microsoft.com/office/drawing/2014/main" id="{CBF53F7E-DC6C-0F13-47ED-C85CE327F3FB}"/>
+              </a:ext>
+            </a:extLst>
+          </p:cNvPr>
+          <p:cNvSpPr>
+            <a:spLocks noGrp="1"/>
+          </p:cNvSpPr>
+          <p:nvPr>
+            <p:ph type="body" idx="1"/>
+          </p:nvPr>
+        </p:nvSpPr>
+        <p:spPr>
+          <a:xfrm>
+            <a:off x="979488" y="2460923"/>
+            <a:ext cx="8771002" cy="7560840"/>
+          </a:xfrm>
+        </p:spPr>
+        <p:txBody>
+          <a:bodyPr>
+            <a:normAutofit/>
+          </a:bodyPr>
+          <a:lstStyle/>
+          <a:p>
+            <a:pPr>
+              <a:spcAft>
+                <a:spcPts val="600"/>
+              </a:spcAft>
+            </a:pPr>
+            <a:r>
+              <a:rPr lang="en-US" dirty="0"/>
+              <a:t>Main-Rework</a:t>
+            </a:r>
+          </a:p>
+          <a:p>
+            <a:pPr marL="457200" indent="-457200">
+              <a:spcAft>
+                <a:spcPts val="600"/>
+              </a:spcAft>
+              <a:buFont typeface="Arial" panose="020B0604020202020204" pitchFamily="34" charset="0"/>
+              <a:buChar char="•"/>
+            </a:pPr>
+            <a:r>
+              <a:rPr lang="en-US" dirty="0"/>
+              <a:t>Neuer </a:t>
+            </a:r>
+            <a:r>
+              <a:rPr lang="en-US" dirty="0" err="1"/>
+              <a:t>Übersichtlicher</a:t>
+            </a:r>
+            <a:r>
+              <a:rPr lang="en-US" dirty="0"/>
+              <a:t> Aufbau </a:t>
+            </a:r>
+          </a:p>
+          <a:p>
+            <a:pPr marL="914400" lvl="1" indent="-457200">
+              <a:spcAft>
+                <a:spcPts val="600"/>
+              </a:spcAft>
+              <a:buFont typeface="Arial" panose="020B0604020202020204" pitchFamily="34" charset="0"/>
+              <a:buChar char="•"/>
+            </a:pPr>
+            <a:r>
+              <a:rPr lang="en-US" dirty="0"/>
+              <a:t>Software </a:t>
+            </a:r>
+          </a:p>
+          <a:p>
+            <a:pPr marL="914400" lvl="1" indent="-457200">
+              <a:spcAft>
+                <a:spcPts val="600"/>
+              </a:spcAft>
+              <a:buFont typeface="Arial" panose="020B0604020202020204" pitchFamily="34" charset="0"/>
+              <a:buChar char="•"/>
+            </a:pPr>
+            <a:r>
+              <a:rPr lang="en-US" dirty="0"/>
+              <a:t>Simulation/</a:t>
+            </a:r>
+            <a:r>
+              <a:rPr lang="en-US" dirty="0" err="1"/>
+              <a:t>Dokumentation</a:t>
+            </a:r>
+            <a:endParaRPr lang="en-US" dirty="0"/>
+          </a:p>
+          <a:p>
+            <a:pPr marL="914400" lvl="1" indent="-457200">
+              <a:spcAft>
+                <a:spcPts val="600"/>
+              </a:spcAft>
+              <a:buFont typeface="Arial" panose="020B0604020202020204" pitchFamily="34" charset="0"/>
+              <a:buChar char="•"/>
+            </a:pPr>
+            <a:r>
+              <a:rPr lang="en-US" dirty="0"/>
+              <a:t>Setup </a:t>
+            </a:r>
+            <a:r>
+              <a:rPr lang="en-US" dirty="0" err="1"/>
+              <a:t>Guid</a:t>
+            </a:r>
+            <a:endParaRPr lang="en-US" dirty="0"/>
+          </a:p>
+          <a:p>
+            <a:pPr lvl="1">
+              <a:spcAft>
+                <a:spcPts val="600"/>
+              </a:spcAft>
+            </a:pPr>
+            <a:endParaRPr lang="en-US" dirty="0"/>
+          </a:p>
+          <a:p>
+            <a:pPr marL="457200" indent="-457200">
+              <a:spcAft>
+                <a:spcPts val="600"/>
+              </a:spcAft>
+              <a:buFont typeface="Arial" panose="020B0604020202020204" pitchFamily="34" charset="0"/>
+              <a:buChar char="•"/>
+            </a:pPr>
+            <a:r>
+              <a:rPr lang="en-US" dirty="0"/>
+              <a:t>READMEs mir </a:t>
+            </a:r>
+            <a:r>
+              <a:rPr lang="en-US" dirty="0" err="1"/>
+              <a:t>erklärungen</a:t>
+            </a:r>
+            <a:r>
+              <a:rPr lang="en-US" dirty="0"/>
+              <a:t> </a:t>
+            </a:r>
+          </a:p>
+          <a:p>
+            <a:pPr marL="457200" indent="-457200">
+              <a:spcAft>
+                <a:spcPts val="600"/>
+              </a:spcAft>
+              <a:buFont typeface="Arial" panose="020B0604020202020204" pitchFamily="34" charset="0"/>
+              <a:buChar char="•"/>
+            </a:pPr>
+            <a:endParaRPr lang="en-US" dirty="0"/>
+          </a:p>
+          <a:p>
+            <a:pPr marL="457200" indent="-457200">
+              <a:spcAft>
+                <a:spcPts val="600"/>
+              </a:spcAft>
+              <a:buFont typeface="Arial" panose="020B0604020202020204" pitchFamily="34" charset="0"/>
+              <a:buChar char="•"/>
+            </a:pPr>
+            <a:r>
+              <a:rPr lang="en-US" dirty="0"/>
+              <a:t>Code-Archive </a:t>
+            </a:r>
+          </a:p>
+          <a:p>
+            <a:pPr marL="457200" indent="-457200">
+              <a:spcAft>
+                <a:spcPts val="600"/>
+              </a:spcAft>
+              <a:buFont typeface="Arial" panose="020B0604020202020204" pitchFamily="34" charset="0"/>
+              <a:buChar char="•"/>
+            </a:pPr>
+            <a:endParaRPr lang="en-US" dirty="0"/>
+          </a:p>
+          <a:p>
+            <a:pPr>
+              <a:spcAft>
+                <a:spcPts val="600"/>
+              </a:spcAft>
+            </a:pPr>
+            <a:endParaRPr lang="de-AT" dirty="0"/>
+          </a:p>
+        </p:txBody>
+      </p:sp>
+      <p:sp>
+        <p:nvSpPr>
+          <p:cNvPr id="4" name="Titel 3">
+            <a:extLst>
+              <a:ext uri="{FF2B5EF4-FFF2-40B4-BE49-F238E27FC236}">
+                <a16:creationId xmlns:a16="http://schemas.microsoft.com/office/drawing/2014/main" id="{F4E0AC2E-E40F-B5EB-9EA1-6618B605182E}"/>
+              </a:ext>
+            </a:extLst>
+          </p:cNvPr>
+          <p:cNvSpPr>
+            <a:spLocks noGrp="1"/>
+          </p:cNvSpPr>
+          <p:nvPr>
+            <p:ph type="title"/>
+          </p:nvPr>
+        </p:nvSpPr>
+        <p:spPr>
+          <a:xfrm>
+            <a:off x="979488" y="588715"/>
+            <a:ext cx="12312922" cy="780637"/>
+          </a:xfrm>
+        </p:spPr>
+        <p:txBody>
+          <a:bodyPr>
+            <a:normAutofit/>
+          </a:bodyPr>
+          <a:lstStyle/>
+          <a:p>
+            <a:r>
+              <a:rPr lang="en-GB" dirty="0" err="1"/>
+              <a:t>Neustrukturiereung</a:t>
+            </a:r>
+            <a:r>
+              <a:rPr lang="en-GB" dirty="0"/>
+              <a:t> </a:t>
+            </a:r>
+            <a:r>
+              <a:rPr lang="en-GB" dirty="0" err="1"/>
+              <a:t>Github</a:t>
+            </a:r>
+            <a:endParaRPr lang="de-AT" dirty="0"/>
+          </a:p>
+        </p:txBody>
+      </p:sp>
+      <p:pic>
+        <p:nvPicPr>
+          <p:cNvPr id="8" name="Inhaltsplatzhalter 7">
+            <a:extLst>
+              <a:ext uri="{FF2B5EF4-FFF2-40B4-BE49-F238E27FC236}">
+                <a16:creationId xmlns:a16="http://schemas.microsoft.com/office/drawing/2014/main" id="{49D5B5DC-F66F-F669-39D5-8B91A478A543}"/>
+              </a:ext>
+            </a:extLst>
+          </p:cNvPr>
+          <p:cNvPicPr>
+            <a:picLocks noGrp="1" noChangeAspect="1"/>
+          </p:cNvPicPr>
+          <p:nvPr>
+            <p:ph sz="half" idx="3"/>
+          </p:nvPr>
+        </p:nvPicPr>
+        <p:blipFill>
+          <a:blip r:embed="rId2"/>
+          <a:stretch>
+            <a:fillRect/>
+          </a:stretch>
+        </p:blipFill>
+        <p:spPr>
+          <a:xfrm>
+            <a:off x="13292410" y="2148679"/>
+            <a:ext cx="4198596" cy="6961191"/>
+          </a:xfrm>
+          <a:prstGeom prst="rect">
+            <a:avLst/>
+          </a:prstGeom>
+        </p:spPr>
+      </p:pic>
+    </p:spTree>
+    <p:extLst>
+      <p:ext uri="{BB962C8B-B14F-4D97-AF65-F5344CB8AC3E}">
+        <p14:creationId xmlns:p14="http://schemas.microsoft.com/office/powerpoint/2010/main" val="1580370205"/>
+      </p:ext>
+    </p:extLst>
+  </p:cSld>
+  <p:clrMapOvr>
+    <a:masterClrMapping/>
+  </p:clrMapOvr>
+</p:sld>
+</file>
+
+<file path=ppt/slides/slide12.xml><?xml version="1.0" encoding="utf-8"?>
+<p:sld xmlns:a="http://schemas.openxmlformats.org/drawingml/2006/main" xmlns:r="http://schemas.openxmlformats.org/officeDocument/2006/relationships" xmlns:p="http://schemas.openxmlformats.org/presentationml/2006/main">
+  <p:cSld>
+    <p:spTree>
+      <p:nvGrpSpPr>
+        <p:cNvPr id="1" name="">
+          <a:extLst>
+            <a:ext uri="{FF2B5EF4-FFF2-40B4-BE49-F238E27FC236}">
+              <a16:creationId xmlns:a16="http://schemas.microsoft.com/office/drawing/2014/main" id="{13093283-DC7B-6C4E-3B20-CAAE397D4F39}"/>
+            </a:ext>
+          </a:extLst>
+        </p:cNvPr>
+        <p:cNvGrpSpPr/>
+        <p:nvPr/>
+      </p:nvGrpSpPr>
+      <p:grpSpPr>
+        <a:xfrm>
+          <a:off x="0" y="0"/>
+          <a:ext cx="0" cy="0"/>
+          <a:chOff x="0" y="0"/>
+          <a:chExt cx="0" cy="0"/>
+        </a:xfrm>
+      </p:grpSpPr>
+      <p:sp>
+        <p:nvSpPr>
+          <p:cNvPr id="3" name="Textplatzhalter 2">
+            <a:extLst>
+              <a:ext uri="{FF2B5EF4-FFF2-40B4-BE49-F238E27FC236}">
+                <a16:creationId xmlns:a16="http://schemas.microsoft.com/office/drawing/2014/main" id="{B32A9C30-7280-98F4-B688-7F7EAAE03CB6}"/>
+              </a:ext>
+            </a:extLst>
+          </p:cNvPr>
+          <p:cNvSpPr>
+            <a:spLocks noGrp="1"/>
+          </p:cNvSpPr>
+          <p:nvPr>
+            <p:ph type="body" idx="1"/>
+          </p:nvPr>
+        </p:nvSpPr>
+        <p:spPr>
+          <a:xfrm>
+            <a:off x="979488" y="2460923"/>
+            <a:ext cx="8771002" cy="7560840"/>
+          </a:xfrm>
+        </p:spPr>
+        <p:txBody>
+          <a:bodyPr>
+            <a:normAutofit/>
+          </a:bodyPr>
+          <a:lstStyle/>
+          <a:p>
+            <a:pPr>
+              <a:spcAft>
+                <a:spcPts val="600"/>
+              </a:spcAft>
+            </a:pPr>
+            <a:r>
+              <a:rPr lang="en-US" dirty="0"/>
+              <a:t>Initialization</a:t>
+            </a:r>
+          </a:p>
+          <a:p>
+            <a:pPr marL="457200" indent="-457200">
+              <a:spcAft>
+                <a:spcPts val="600"/>
+              </a:spcAft>
+              <a:buFont typeface="Arial" panose="020B0604020202020204" pitchFamily="34" charset="0"/>
+              <a:buChar char="•"/>
+            </a:pPr>
+            <a:r>
+              <a:rPr lang="en-US" dirty="0" err="1"/>
+              <a:t>Prüfen</a:t>
+            </a:r>
+            <a:r>
+              <a:rPr lang="en-US" dirty="0"/>
+              <a:t> </a:t>
+            </a:r>
+            <a:r>
+              <a:rPr lang="en-US" dirty="0" err="1"/>
+              <a:t>ob</a:t>
+            </a:r>
+            <a:r>
+              <a:rPr lang="en-US" dirty="0"/>
+              <a:t> Raspberry </a:t>
+            </a:r>
+            <a:r>
+              <a:rPr lang="en-US" dirty="0" err="1"/>
+              <a:t>läuft</a:t>
+            </a:r>
+            <a:endParaRPr lang="en-US" dirty="0"/>
+          </a:p>
+          <a:p>
+            <a:pPr marL="457200" indent="-457200">
+              <a:spcAft>
+                <a:spcPts val="600"/>
+              </a:spcAft>
+              <a:buFont typeface="Arial" panose="020B0604020202020204" pitchFamily="34" charset="0"/>
+              <a:buChar char="•"/>
+            </a:pPr>
+            <a:endParaRPr lang="en-US" dirty="0"/>
+          </a:p>
+          <a:p>
+            <a:pPr marL="457200" indent="-457200">
+              <a:spcAft>
+                <a:spcPts val="600"/>
+              </a:spcAft>
+              <a:buFont typeface="Arial" panose="020B0604020202020204" pitchFamily="34" charset="0"/>
+              <a:buChar char="•"/>
+            </a:pPr>
+            <a:r>
+              <a:rPr lang="en-US" dirty="0"/>
+              <a:t>Bild </a:t>
+            </a:r>
+            <a:r>
+              <a:rPr lang="en-US" dirty="0" err="1"/>
+              <a:t>wird</a:t>
+            </a:r>
+            <a:r>
+              <a:rPr lang="en-US" dirty="0"/>
+              <a:t> </a:t>
+            </a:r>
+            <a:r>
+              <a:rPr lang="en-US" dirty="0" err="1"/>
+              <a:t>zerlegt</a:t>
+            </a:r>
+            <a:r>
+              <a:rPr lang="en-US" dirty="0"/>
+              <a:t> </a:t>
+            </a:r>
+          </a:p>
+          <a:p>
+            <a:pPr>
+              <a:spcAft>
+                <a:spcPts val="600"/>
+              </a:spcAft>
+            </a:pPr>
+            <a:endParaRPr lang="en-US" dirty="0"/>
+          </a:p>
+          <a:p>
+            <a:pPr marL="457200" indent="-457200">
+              <a:spcAft>
+                <a:spcPts val="600"/>
+              </a:spcAft>
+              <a:buFont typeface="Arial" panose="020B0604020202020204" pitchFamily="34" charset="0"/>
+              <a:buChar char="•"/>
+            </a:pPr>
+            <a:r>
+              <a:rPr lang="en-US" dirty="0"/>
+              <a:t>2. 4. und 6. Matrix </a:t>
+            </a:r>
+            <a:r>
+              <a:rPr lang="en-US" dirty="0" err="1"/>
+              <a:t>wird</a:t>
+            </a:r>
+            <a:r>
+              <a:rPr lang="en-US" dirty="0"/>
+              <a:t> </a:t>
+            </a:r>
+            <a:r>
+              <a:rPr lang="en-US" dirty="0" err="1"/>
+              <a:t>geflippt</a:t>
+            </a:r>
+            <a:r>
+              <a:rPr lang="en-US" dirty="0"/>
+              <a:t> </a:t>
+            </a:r>
+          </a:p>
+          <a:p>
+            <a:pPr marL="457200" indent="-457200">
+              <a:spcAft>
+                <a:spcPts val="600"/>
+              </a:spcAft>
+              <a:buFont typeface="Arial" panose="020B0604020202020204" pitchFamily="34" charset="0"/>
+              <a:buChar char="•"/>
+            </a:pPr>
+            <a:endParaRPr lang="en-US" dirty="0"/>
+          </a:p>
+          <a:p>
+            <a:pPr marL="457200" indent="-457200">
+              <a:spcAft>
+                <a:spcPts val="600"/>
+              </a:spcAft>
+              <a:buFont typeface="Arial" panose="020B0604020202020204" pitchFamily="34" charset="0"/>
+              <a:buChar char="•"/>
+            </a:pPr>
+            <a:r>
+              <a:rPr lang="en-US" dirty="0"/>
+              <a:t>In PIL-Image </a:t>
+            </a:r>
+            <a:r>
+              <a:rPr lang="en-US" dirty="0" err="1"/>
+              <a:t>converten</a:t>
+            </a:r>
+            <a:endParaRPr lang="en-US" dirty="0"/>
+          </a:p>
+          <a:p>
+            <a:pPr marL="457200" indent="-457200">
+              <a:spcAft>
+                <a:spcPts val="600"/>
+              </a:spcAft>
+              <a:buFont typeface="Arial" panose="020B0604020202020204" pitchFamily="34" charset="0"/>
+              <a:buChar char="•"/>
+            </a:pPr>
+            <a:endParaRPr lang="en-US" dirty="0"/>
+          </a:p>
+          <a:p>
+            <a:pPr marL="457200" indent="-457200">
+              <a:spcAft>
+                <a:spcPts val="600"/>
+              </a:spcAft>
+              <a:buFont typeface="Arial" panose="020B0604020202020204" pitchFamily="34" charset="0"/>
+              <a:buChar char="•"/>
+            </a:pPr>
+            <a:r>
+              <a:rPr lang="en-US" dirty="0" err="1"/>
+              <a:t>Anzeigen</a:t>
+            </a:r>
+            <a:endParaRPr lang="en-US" dirty="0"/>
+          </a:p>
+          <a:p>
+            <a:pPr>
+              <a:spcAft>
+                <a:spcPts val="600"/>
+              </a:spcAft>
+            </a:pPr>
+            <a:endParaRPr lang="de-AT" dirty="0"/>
+          </a:p>
+        </p:txBody>
+      </p:sp>
+      <p:sp>
+        <p:nvSpPr>
+          <p:cNvPr id="4" name="Titel 3">
+            <a:extLst>
+              <a:ext uri="{FF2B5EF4-FFF2-40B4-BE49-F238E27FC236}">
+                <a16:creationId xmlns:a16="http://schemas.microsoft.com/office/drawing/2014/main" id="{CFCAEF52-D90D-D668-F92E-0CF07831AF05}"/>
+              </a:ext>
+            </a:extLst>
+          </p:cNvPr>
+          <p:cNvSpPr>
+            <a:spLocks noGrp="1"/>
+          </p:cNvSpPr>
+          <p:nvPr>
+            <p:ph type="title"/>
+          </p:nvPr>
+        </p:nvSpPr>
+        <p:spPr>
+          <a:xfrm>
+            <a:off x="979488" y="588715"/>
+            <a:ext cx="12312922" cy="780637"/>
+          </a:xfrm>
+        </p:spPr>
+        <p:txBody>
+          <a:bodyPr>
+            <a:normAutofit/>
+          </a:bodyPr>
+          <a:lstStyle/>
+          <a:p>
+            <a:r>
+              <a:rPr lang="en-GB" dirty="0" err="1"/>
+              <a:t>Programm</a:t>
+            </a:r>
+            <a:r>
+              <a:rPr lang="en-GB" dirty="0"/>
+              <a:t> Start</a:t>
+            </a:r>
+            <a:endParaRPr lang="de-AT" dirty="0"/>
+          </a:p>
+        </p:txBody>
+      </p:sp>
+      <p:pic>
+        <p:nvPicPr>
+          <p:cNvPr id="8" name="Inhaltsplatzhalter 7">
+            <a:extLst>
+              <a:ext uri="{FF2B5EF4-FFF2-40B4-BE49-F238E27FC236}">
+                <a16:creationId xmlns:a16="http://schemas.microsoft.com/office/drawing/2014/main" id="{D717FCA4-983C-CFB4-2036-1A693D41FA7C}"/>
+              </a:ext>
+            </a:extLst>
+          </p:cNvPr>
+          <p:cNvPicPr>
+            <a:picLocks noGrp="1" noChangeAspect="1"/>
+          </p:cNvPicPr>
+          <p:nvPr>
+            <p:ph sz="half" idx="3"/>
+          </p:nvPr>
+        </p:nvPicPr>
+        <p:blipFill>
+          <a:blip r:embed="rId2">
+            <a:extLst>
+              <a:ext uri="{28A0092B-C50C-407E-A947-70E740481C1C}">
+                <a14:useLocalDpi xmlns:a14="http://schemas.microsoft.com/office/drawing/2010/main" val="0"/>
+              </a:ext>
+            </a:extLst>
+          </a:blip>
+          <a:stretch>
+            <a:fillRect/>
+          </a:stretch>
+        </p:blipFill>
+        <p:spPr>
+          <a:xfrm>
+            <a:off x="12228777" y="2460625"/>
+            <a:ext cx="5039783" cy="7559675"/>
+          </a:xfrm>
+          <a:prstGeom prst="rect">
+            <a:avLst/>
+          </a:prstGeom>
+        </p:spPr>
+      </p:pic>
+    </p:spTree>
+    <p:extLst>
+      <p:ext uri="{BB962C8B-B14F-4D97-AF65-F5344CB8AC3E}">
+        <p14:creationId xmlns:p14="http://schemas.microsoft.com/office/powerpoint/2010/main" val="3422688772"/>
+      </p:ext>
+    </p:extLst>
+  </p:cSld>
+  <p:clrMapOvr>
+    <a:masterClrMapping/>
+  </p:clrMapOvr>
+</p:sld>
+</file>
+
+<file path=ppt/slides/slide13.xml><?xml version="1.0" encoding="utf-8"?>
+<p:sld xmlns:a="http://schemas.openxmlformats.org/drawingml/2006/main" xmlns:r="http://schemas.openxmlformats.org/officeDocument/2006/relationships" xmlns:p="http://schemas.openxmlformats.org/presentationml/2006/main">
+  <p:cSld>
+    <p:spTree>
+      <p:nvGrpSpPr>
+        <p:cNvPr id="1" name="">
+          <a:extLst>
+            <a:ext uri="{FF2B5EF4-FFF2-40B4-BE49-F238E27FC236}">
+              <a16:creationId xmlns:a16="http://schemas.microsoft.com/office/drawing/2014/main" id="{242A4EF3-ACD0-4114-728A-B46CA13BA648}"/>
+            </a:ext>
+          </a:extLst>
+        </p:cNvPr>
+        <p:cNvGrpSpPr/>
+        <p:nvPr/>
+      </p:nvGrpSpPr>
+      <p:grpSpPr>
+        <a:xfrm>
+          <a:off x="0" y="0"/>
+          <a:ext cx="0" cy="0"/>
+          <a:chOff x="0" y="0"/>
+          <a:chExt cx="0" cy="0"/>
+        </a:xfrm>
+      </p:grpSpPr>
+      <p:sp>
+        <p:nvSpPr>
+          <p:cNvPr id="3" name="Textplatzhalter 2">
+            <a:extLst>
+              <a:ext uri="{FF2B5EF4-FFF2-40B4-BE49-F238E27FC236}">
+                <a16:creationId xmlns:a16="http://schemas.microsoft.com/office/drawing/2014/main" id="{EF5BAFAE-DDBE-748C-F5EA-E1655493AE7C}"/>
+              </a:ext>
+            </a:extLst>
+          </p:cNvPr>
+          <p:cNvSpPr>
+            <a:spLocks noGrp="1"/>
+          </p:cNvSpPr>
+          <p:nvPr>
+            <p:ph type="body" idx="1"/>
+          </p:nvPr>
+        </p:nvSpPr>
+        <p:spPr>
+          <a:xfrm>
+            <a:off x="979488" y="2460923"/>
+            <a:ext cx="8771002" cy="7560840"/>
+          </a:xfrm>
+        </p:spPr>
+        <p:txBody>
+          <a:bodyPr>
+            <a:normAutofit/>
+          </a:bodyPr>
+          <a:lstStyle/>
+          <a:p>
+            <a:pPr>
+              <a:spcAft>
+                <a:spcPts val="600"/>
+              </a:spcAft>
+            </a:pPr>
+            <a:r>
+              <a:rPr lang="en-US" dirty="0" err="1"/>
+              <a:t>Stichpunkte</a:t>
+            </a:r>
+            <a:endParaRPr lang="en-US" dirty="0"/>
+          </a:p>
+          <a:p>
+            <a:pPr marL="457200" indent="-457200">
+              <a:spcAft>
+                <a:spcPts val="600"/>
+              </a:spcAft>
+              <a:buFont typeface="Arial" panose="020B0604020202020204" pitchFamily="34" charset="0"/>
+              <a:buChar char="•"/>
+            </a:pPr>
+            <a:r>
+              <a:rPr lang="en-US" dirty="0"/>
+              <a:t>Material der Wahl : Holz</a:t>
+            </a:r>
+          </a:p>
+          <a:p>
+            <a:pPr marL="457200" indent="-457200">
+              <a:spcAft>
+                <a:spcPts val="600"/>
+              </a:spcAft>
+              <a:buFont typeface="Arial" panose="020B0604020202020204" pitchFamily="34" charset="0"/>
+              <a:buChar char="•"/>
+            </a:pPr>
+            <a:endParaRPr lang="en-US" dirty="0"/>
+          </a:p>
+          <a:p>
+            <a:pPr marL="457200" indent="-457200">
+              <a:spcAft>
+                <a:spcPts val="600"/>
+              </a:spcAft>
+              <a:buFont typeface="Arial" panose="020B0604020202020204" pitchFamily="34" charset="0"/>
+              <a:buChar char="•"/>
+            </a:pPr>
+            <a:r>
+              <a:rPr lang="en-US" dirty="0"/>
+              <a:t>Design </a:t>
+            </a:r>
+            <a:r>
+              <a:rPr lang="en-US" dirty="0" err="1"/>
+              <a:t>Finalisiert</a:t>
+            </a:r>
+            <a:endParaRPr lang="en-US" dirty="0"/>
+          </a:p>
+          <a:p>
+            <a:pPr>
+              <a:spcAft>
+                <a:spcPts val="600"/>
+              </a:spcAft>
+            </a:pPr>
+            <a:endParaRPr lang="en-US" dirty="0"/>
+          </a:p>
+          <a:p>
+            <a:pPr marL="457200" indent="-457200">
+              <a:spcAft>
+                <a:spcPts val="600"/>
+              </a:spcAft>
+              <a:buFont typeface="Arial" panose="020B0604020202020204" pitchFamily="34" charset="0"/>
+              <a:buChar char="•"/>
+            </a:pPr>
+            <a:r>
+              <a:rPr lang="en-US" dirty="0"/>
+              <a:t>Für </a:t>
+            </a:r>
+            <a:r>
+              <a:rPr lang="en-US" dirty="0" err="1"/>
+              <a:t>Optimales</a:t>
+            </a:r>
+            <a:r>
+              <a:rPr lang="en-US" dirty="0"/>
+              <a:t> </a:t>
+            </a:r>
+            <a:r>
+              <a:rPr lang="en-US" dirty="0" err="1"/>
+              <a:t>gerades</a:t>
+            </a:r>
+            <a:r>
+              <a:rPr lang="en-US" dirty="0"/>
+              <a:t> Bild</a:t>
+            </a:r>
+          </a:p>
+          <a:p>
+            <a:pPr marL="914400" lvl="1" indent="-457200">
+              <a:spcAft>
+                <a:spcPts val="600"/>
+              </a:spcAft>
+              <a:buFont typeface="Arial" panose="020B0604020202020204" pitchFamily="34" charset="0"/>
+              <a:buChar char="•"/>
+            </a:pPr>
+            <a:r>
+              <a:rPr lang="en-US" dirty="0"/>
+              <a:t>Opt1: LED-Matrix </a:t>
+            </a:r>
+            <a:r>
+              <a:rPr lang="en-US" dirty="0" err="1"/>
+              <a:t>Einzelteile</a:t>
+            </a:r>
+            <a:r>
+              <a:rPr lang="en-US" dirty="0"/>
+              <a:t> </a:t>
+            </a:r>
+            <a:r>
+              <a:rPr lang="en-US" dirty="0" err="1"/>
+              <a:t>Abschleifen</a:t>
+            </a:r>
+            <a:endParaRPr lang="en-US" dirty="0"/>
+          </a:p>
+          <a:p>
+            <a:pPr marL="914400" lvl="1" indent="-457200">
+              <a:spcAft>
+                <a:spcPts val="600"/>
+              </a:spcAft>
+              <a:buFont typeface="Arial" panose="020B0604020202020204" pitchFamily="34" charset="0"/>
+              <a:buChar char="•"/>
+            </a:pPr>
+            <a:r>
+              <a:rPr lang="en-US" dirty="0"/>
+              <a:t>Opt2: </a:t>
+            </a:r>
+            <a:r>
+              <a:rPr lang="en-US" dirty="0" err="1"/>
+              <a:t>Neuabmessung</a:t>
+            </a:r>
+            <a:r>
+              <a:rPr lang="en-US" dirty="0"/>
+              <a:t> der </a:t>
+            </a:r>
+            <a:r>
+              <a:rPr lang="en-US" dirty="0" err="1"/>
+              <a:t>Platinen</a:t>
+            </a:r>
+            <a:endParaRPr lang="en-US" dirty="0"/>
+          </a:p>
+          <a:p>
+            <a:pPr lvl="1">
+              <a:spcAft>
+                <a:spcPts val="600"/>
+              </a:spcAft>
+            </a:pPr>
+            <a:endParaRPr lang="en-US" dirty="0"/>
+          </a:p>
+          <a:p>
+            <a:pPr marL="457200" indent="-457200">
+              <a:spcAft>
+                <a:spcPts val="600"/>
+              </a:spcAft>
+              <a:buFont typeface="Arial" panose="020B0604020202020204" pitchFamily="34" charset="0"/>
+              <a:buChar char="•"/>
+            </a:pPr>
+            <a:r>
+              <a:rPr lang="en-US" dirty="0"/>
+              <a:t>Wenn </a:t>
+            </a:r>
+            <a:r>
+              <a:rPr lang="en-US" dirty="0" err="1"/>
+              <a:t>Genug</a:t>
+            </a:r>
+            <a:r>
+              <a:rPr lang="en-US" dirty="0"/>
+              <a:t> Zeit Case2.0</a:t>
+            </a:r>
+          </a:p>
+          <a:p>
+            <a:pPr>
+              <a:spcAft>
+                <a:spcPts val="600"/>
+              </a:spcAft>
+            </a:pPr>
+            <a:endParaRPr lang="en-US" dirty="0"/>
+          </a:p>
+        </p:txBody>
+      </p:sp>
+      <p:sp>
+        <p:nvSpPr>
+          <p:cNvPr id="4" name="Titel 3">
+            <a:extLst>
+              <a:ext uri="{FF2B5EF4-FFF2-40B4-BE49-F238E27FC236}">
+                <a16:creationId xmlns:a16="http://schemas.microsoft.com/office/drawing/2014/main" id="{2226DA8B-247A-9B05-05E8-5F0573F84A17}"/>
+              </a:ext>
+            </a:extLst>
+          </p:cNvPr>
+          <p:cNvSpPr>
+            <a:spLocks noGrp="1"/>
+          </p:cNvSpPr>
+          <p:nvPr>
+            <p:ph type="title"/>
+          </p:nvPr>
+        </p:nvSpPr>
+        <p:spPr>
+          <a:xfrm>
+            <a:off x="979488" y="588715"/>
+            <a:ext cx="12312922" cy="780637"/>
+          </a:xfrm>
+        </p:spPr>
+        <p:txBody>
+          <a:bodyPr>
+            <a:normAutofit/>
+          </a:bodyPr>
+          <a:lstStyle/>
+          <a:p>
+            <a:r>
+              <a:rPr lang="en-GB" dirty="0"/>
+              <a:t>Case Design</a:t>
+            </a:r>
+            <a:endParaRPr lang="de-AT" dirty="0"/>
+          </a:p>
+        </p:txBody>
+      </p:sp>
+      <p:pic>
+        <p:nvPicPr>
+          <p:cNvPr id="6" name="Inhaltsplatzhalter 6" descr="Ein Bild, das Rechteck, Muster enthält.&#10;&#10;KI-generierte Inhalte können fehlerhaft sein.">
+            <a:extLst>
+              <a:ext uri="{FF2B5EF4-FFF2-40B4-BE49-F238E27FC236}">
+                <a16:creationId xmlns:a16="http://schemas.microsoft.com/office/drawing/2014/main" id="{15C0448F-A25E-E14E-F89D-5C72D686E4DA}"/>
+              </a:ext>
+            </a:extLst>
+          </p:cNvPr>
+          <p:cNvPicPr>
+            <a:picLocks noGrp="1" noChangeAspect="1"/>
+          </p:cNvPicPr>
+          <p:nvPr>
+            <p:ph sz="half" idx="3"/>
+          </p:nvPr>
+        </p:nvPicPr>
+        <p:blipFill>
+          <a:blip r:embed="rId2"/>
+          <a:stretch>
+            <a:fillRect/>
+          </a:stretch>
+        </p:blipFill>
+        <p:spPr>
+          <a:xfrm>
+            <a:off x="12323111" y="1314961"/>
+            <a:ext cx="5611008" cy="3762900"/>
+          </a:xfrm>
+          <a:prstGeom prst="rect">
+            <a:avLst/>
+          </a:prstGeom>
+          <a:noFill/>
+          <a:ln>
+            <a:noFill/>
+          </a:ln>
+          <a:effectLst>
+            <a:outerShdw blurRad="292100" dist="139700" dir="2700000" algn="tl" rotWithShape="0">
+              <a:srgbClr val="333333">
+                <a:alpha val="65000"/>
+              </a:srgbClr>
+            </a:outerShdw>
+          </a:effectLst>
+        </p:spPr>
+      </p:pic>
+      <p:pic>
+        <p:nvPicPr>
+          <p:cNvPr id="5" name="Grafik 4">
+            <a:extLst>
+              <a:ext uri="{FF2B5EF4-FFF2-40B4-BE49-F238E27FC236}">
+                <a16:creationId xmlns:a16="http://schemas.microsoft.com/office/drawing/2014/main" id="{A7ED326C-55F6-2B6B-458B-59A1C13F3CF4}"/>
+              </a:ext>
+            </a:extLst>
+          </p:cNvPr>
+          <p:cNvPicPr>
+            <a:picLocks noChangeAspect="1"/>
+          </p:cNvPicPr>
+          <p:nvPr/>
+        </p:nvPicPr>
+        <p:blipFill>
+          <a:blip r:embed="rId3"/>
+          <a:stretch>
+            <a:fillRect/>
+          </a:stretch>
+        </p:blipFill>
+        <p:spPr>
+          <a:xfrm>
+            <a:off x="10916147" y="5023470"/>
+            <a:ext cx="3816424" cy="4972916"/>
+          </a:xfrm>
+          <a:prstGeom prst="rect">
+            <a:avLst/>
+          </a:prstGeom>
+        </p:spPr>
+      </p:pic>
+      <p:pic>
+        <p:nvPicPr>
+          <p:cNvPr id="8" name="Grafik 7">
+            <a:extLst>
+              <a:ext uri="{FF2B5EF4-FFF2-40B4-BE49-F238E27FC236}">
+                <a16:creationId xmlns:a16="http://schemas.microsoft.com/office/drawing/2014/main" id="{A46DF89F-22D3-F1C2-965B-2B1FB9F259C4}"/>
+              </a:ext>
+            </a:extLst>
+          </p:cNvPr>
+          <p:cNvPicPr>
+            <a:picLocks noChangeAspect="1"/>
+          </p:cNvPicPr>
+          <p:nvPr/>
+        </p:nvPicPr>
+        <p:blipFill>
+          <a:blip r:embed="rId4"/>
+          <a:stretch>
+            <a:fillRect/>
+          </a:stretch>
+        </p:blipFill>
+        <p:spPr>
+          <a:xfrm>
+            <a:off x="15524658" y="5023470"/>
+            <a:ext cx="4134041" cy="4968552"/>
+          </a:xfrm>
+          <a:prstGeom prst="rect">
+            <a:avLst/>
+          </a:prstGeom>
+        </p:spPr>
+      </p:pic>
+    </p:spTree>
+    <p:extLst>
+      <p:ext uri="{BB962C8B-B14F-4D97-AF65-F5344CB8AC3E}">
+        <p14:creationId xmlns:p14="http://schemas.microsoft.com/office/powerpoint/2010/main" val="3211099167"/>
+      </p:ext>
+    </p:extLst>
+  </p:cSld>
+  <p:clrMapOvr>
+    <a:masterClrMapping/>
+  </p:clrMapOvr>
+</p:sld>
+</file>
+
+<file path=ppt/slides/slide14.xml><?xml version="1.0" encoding="utf-8"?>
+<p:sld xmlns:a="http://schemas.openxmlformats.org/drawingml/2006/main" xmlns:r="http://schemas.openxmlformats.org/officeDocument/2006/relationships" xmlns:p="http://schemas.openxmlformats.org/presentationml/2006/main">
+  <p:cSld>
+    <p:spTree>
+      <p:nvGrpSpPr>
+        <p:cNvPr id="1" name="">
+          <a:extLst>
+            <a:ext uri="{FF2B5EF4-FFF2-40B4-BE49-F238E27FC236}">
+              <a16:creationId xmlns:a16="http://schemas.microsoft.com/office/drawing/2014/main" id="{D4DD3ABA-42A8-C6F4-B2B0-C6599B158F39}"/>
+            </a:ext>
+          </a:extLst>
+        </p:cNvPr>
+        <p:cNvGrpSpPr/>
+        <p:nvPr/>
+      </p:nvGrpSpPr>
+      <p:grpSpPr>
+        <a:xfrm>
+          <a:off x="0" y="0"/>
+          <a:ext cx="0" cy="0"/>
+          <a:chOff x="0" y="0"/>
+          <a:chExt cx="0" cy="0"/>
+        </a:xfrm>
+      </p:grpSpPr>
+      <p:sp>
+        <p:nvSpPr>
+          <p:cNvPr id="3" name="Textplatzhalter 2">
+            <a:extLst>
+              <a:ext uri="{FF2B5EF4-FFF2-40B4-BE49-F238E27FC236}">
+                <a16:creationId xmlns:a16="http://schemas.microsoft.com/office/drawing/2014/main" id="{0AE5939C-8D9C-51D3-B3DD-95DCA2FF40D9}"/>
+              </a:ext>
+            </a:extLst>
+          </p:cNvPr>
+          <p:cNvSpPr>
+            <a:spLocks noGrp="1"/>
+          </p:cNvSpPr>
+          <p:nvPr>
+            <p:ph type="body" idx="1"/>
+          </p:nvPr>
+        </p:nvSpPr>
+        <p:spPr>
+          <a:xfrm>
+            <a:off x="979488" y="2460923"/>
+            <a:ext cx="8771002" cy="7560840"/>
+          </a:xfrm>
+        </p:spPr>
+        <p:txBody>
+          <a:bodyPr>
+            <a:normAutofit/>
+          </a:bodyPr>
+          <a:lstStyle/>
+          <a:p>
+            <a:pPr>
+              <a:spcAft>
+                <a:spcPts val="600"/>
+              </a:spcAft>
+            </a:pPr>
+            <a:r>
+              <a:rPr lang="en-US" dirty="0" err="1"/>
+              <a:t>Stichpunkte</a:t>
+            </a:r>
+            <a:endParaRPr lang="en-US" dirty="0"/>
+          </a:p>
+          <a:p>
+            <a:pPr marL="457200" indent="-457200">
+              <a:spcAft>
+                <a:spcPts val="600"/>
+              </a:spcAft>
+              <a:buFont typeface="Arial" panose="020B0604020202020204" pitchFamily="34" charset="0"/>
+              <a:buChar char="•"/>
+            </a:pPr>
+            <a:r>
+              <a:rPr lang="en-US" dirty="0" err="1"/>
+              <a:t>Erster</a:t>
+            </a:r>
+            <a:r>
+              <a:rPr lang="en-US" dirty="0"/>
+              <a:t> simpler Aufbau</a:t>
+            </a:r>
+          </a:p>
+          <a:p>
+            <a:pPr>
+              <a:spcAft>
+                <a:spcPts val="600"/>
+              </a:spcAft>
+            </a:pPr>
+            <a:endParaRPr lang="en-US" dirty="0"/>
+          </a:p>
+          <a:p>
+            <a:pPr marL="457200" indent="-457200">
+              <a:spcAft>
+                <a:spcPts val="600"/>
+              </a:spcAft>
+              <a:buFont typeface="Arial" panose="020B0604020202020204" pitchFamily="34" charset="0"/>
+              <a:buChar char="•"/>
+            </a:pPr>
+            <a:r>
+              <a:rPr lang="en-US" dirty="0"/>
+              <a:t>Redesign der </a:t>
+            </a:r>
+            <a:r>
+              <a:rPr lang="en-US" dirty="0" err="1"/>
+              <a:t>neuen</a:t>
+            </a:r>
+            <a:r>
+              <a:rPr lang="en-US" dirty="0"/>
+              <a:t> </a:t>
+            </a:r>
+            <a:r>
+              <a:rPr lang="en-US" dirty="0" err="1"/>
+              <a:t>Platinen</a:t>
+            </a:r>
+            <a:r>
+              <a:rPr lang="en-US" dirty="0"/>
+              <a:t> für </a:t>
+            </a:r>
+            <a:r>
+              <a:rPr lang="en-US" dirty="0" err="1"/>
+              <a:t>neue</a:t>
+            </a:r>
+            <a:r>
+              <a:rPr lang="en-US" dirty="0"/>
+              <a:t> </a:t>
+            </a:r>
+            <a:r>
+              <a:rPr lang="en-US" dirty="0" err="1"/>
+              <a:t>Bauteile</a:t>
+            </a:r>
+            <a:endParaRPr lang="en-US" dirty="0"/>
+          </a:p>
+          <a:p>
+            <a:pPr>
+              <a:spcAft>
+                <a:spcPts val="600"/>
+              </a:spcAft>
+            </a:pPr>
+            <a:endParaRPr lang="en-US" dirty="0"/>
+          </a:p>
+          <a:p>
+            <a:pPr marL="457200" indent="-457200">
+              <a:spcAft>
+                <a:spcPts val="600"/>
+              </a:spcAft>
+              <a:buFont typeface="Arial" panose="020B0604020202020204" pitchFamily="34" charset="0"/>
+              <a:buChar char="•"/>
+            </a:pPr>
+            <a:r>
+              <a:rPr lang="en-US" dirty="0" err="1"/>
+              <a:t>Bestellen</a:t>
+            </a:r>
+            <a:endParaRPr lang="en-US" dirty="0"/>
+          </a:p>
+          <a:p>
+            <a:pPr marL="457200" indent="-457200">
+              <a:spcAft>
+                <a:spcPts val="600"/>
+              </a:spcAft>
+              <a:buFont typeface="Arial" panose="020B0604020202020204" pitchFamily="34" charset="0"/>
+              <a:buChar char="•"/>
+            </a:pPr>
+            <a:endParaRPr lang="en-US" dirty="0"/>
+          </a:p>
+          <a:p>
+            <a:pPr lvl="1">
+              <a:spcAft>
+                <a:spcPts val="600"/>
+              </a:spcAft>
+            </a:pPr>
+            <a:endParaRPr lang="en-US" dirty="0"/>
+          </a:p>
+        </p:txBody>
+      </p:sp>
+      <p:sp>
+        <p:nvSpPr>
+          <p:cNvPr id="4" name="Titel 3">
+            <a:extLst>
+              <a:ext uri="{FF2B5EF4-FFF2-40B4-BE49-F238E27FC236}">
+                <a16:creationId xmlns:a16="http://schemas.microsoft.com/office/drawing/2014/main" id="{9CFD916A-375B-86B3-0DE6-0FA89F3B0B39}"/>
+              </a:ext>
+            </a:extLst>
+          </p:cNvPr>
+          <p:cNvSpPr>
+            <a:spLocks noGrp="1"/>
+          </p:cNvSpPr>
+          <p:nvPr>
+            <p:ph type="title"/>
+          </p:nvPr>
+        </p:nvSpPr>
+        <p:spPr>
+          <a:xfrm>
+            <a:off x="979488" y="588715"/>
+            <a:ext cx="12312922" cy="780637"/>
+          </a:xfrm>
+        </p:spPr>
+        <p:txBody>
+          <a:bodyPr>
+            <a:normAutofit/>
+          </a:bodyPr>
+          <a:lstStyle/>
+          <a:p>
+            <a:r>
+              <a:rPr lang="en-GB" dirty="0"/>
+              <a:t>Design der </a:t>
+            </a:r>
+            <a:r>
+              <a:rPr lang="en-GB" dirty="0" err="1"/>
+              <a:t>Platinen</a:t>
+            </a:r>
+            <a:endParaRPr lang="de-AT" dirty="0"/>
+          </a:p>
+        </p:txBody>
+      </p:sp>
+      <p:pic>
+        <p:nvPicPr>
+          <p:cNvPr id="2" name="Inhaltsplatzhalter 1">
+            <a:extLst>
+              <a:ext uri="{FF2B5EF4-FFF2-40B4-BE49-F238E27FC236}">
+                <a16:creationId xmlns:a16="http://schemas.microsoft.com/office/drawing/2014/main" id="{C0F58BD6-4224-522D-2E6D-7A1DA7015111}"/>
+              </a:ext>
+            </a:extLst>
+          </p:cNvPr>
+          <p:cNvPicPr>
+            <a:picLocks noGrp="1" noChangeAspect="1"/>
+          </p:cNvPicPr>
+          <p:nvPr>
+            <p:ph sz="half" idx="3"/>
+          </p:nvPr>
+        </p:nvPicPr>
+        <p:blipFill>
+          <a:blip r:embed="rId2"/>
+          <a:stretch>
+            <a:fillRect/>
+          </a:stretch>
+        </p:blipFill>
+        <p:spPr>
+          <a:xfrm>
+            <a:off x="10502437" y="2646559"/>
+            <a:ext cx="8492464" cy="7187807"/>
+          </a:xfrm>
+          <a:prstGeom prst="rect">
+            <a:avLst/>
+          </a:prstGeom>
+        </p:spPr>
+      </p:pic>
+    </p:spTree>
+    <p:extLst>
+      <p:ext uri="{BB962C8B-B14F-4D97-AF65-F5344CB8AC3E}">
+        <p14:creationId xmlns:p14="http://schemas.microsoft.com/office/powerpoint/2010/main" val="2252514995"/>
+      </p:ext>
+    </p:extLst>
+  </p:cSld>
+  <p:clrMapOvr>
+    <a:masterClrMapping/>
+  </p:clrMapOvr>
+</p:sld>
+</file>
+
+<file path=ppt/slides/slide15.xml><?xml version="1.0" encoding="utf-8"?>
+<p:sld xmlns:a="http://schemas.openxmlformats.org/drawingml/2006/main" xmlns:r="http://schemas.openxmlformats.org/officeDocument/2006/relationships" xmlns:p="http://schemas.openxmlformats.org/presentationml/2006/main">
+  <p:cSld>
+    <p:spTree>
+      <p:nvGrpSpPr>
+        <p:cNvPr id="1" name=""/>
+        <p:cNvGrpSpPr/>
+        <p:nvPr/>
+      </p:nvGrpSpPr>
+      <p:grpSpPr>
+        <a:xfrm>
+          <a:off x="0" y="0"/>
+          <a:ext cx="0" cy="0"/>
+          <a:chOff x="0" y="0"/>
+          <a:chExt cx="0" cy="0"/>
+        </a:xfrm>
+      </p:grpSpPr>
+      <p:sp>
+        <p:nvSpPr>
+          <p:cNvPr id="2" name="Inhaltsplatzhalter 1">
+            <a:extLst>
+              <a:ext uri="{FF2B5EF4-FFF2-40B4-BE49-F238E27FC236}">
+                <a16:creationId xmlns:a16="http://schemas.microsoft.com/office/drawing/2014/main" id="{8F891062-4DE5-980F-9822-DE3F01123C2F}"/>
+              </a:ext>
+            </a:extLst>
+          </p:cNvPr>
+          <p:cNvSpPr>
+            <a:spLocks noGrp="1"/>
+          </p:cNvSpPr>
+          <p:nvPr>
+            <p:ph sz="half" idx="3"/>
+          </p:nvPr>
+        </p:nvSpPr>
+        <p:spPr/>
+        <p:txBody>
+          <a:bodyPr/>
+          <a:lstStyle/>
+          <a:p>
+            <a:endParaRPr lang="de-AT"/>
+          </a:p>
+        </p:txBody>
+      </p:sp>
+      <p:sp>
+        <p:nvSpPr>
+          <p:cNvPr id="3" name="Textplatzhalter 2">
+            <a:extLst>
+              <a:ext uri="{FF2B5EF4-FFF2-40B4-BE49-F238E27FC236}">
+                <a16:creationId xmlns:a16="http://schemas.microsoft.com/office/drawing/2014/main" id="{AB0485A9-E8D5-47BE-EB56-EFFA6744E50C}"/>
+              </a:ext>
+            </a:extLst>
+          </p:cNvPr>
+          <p:cNvSpPr>
+            <a:spLocks noGrp="1"/>
+          </p:cNvSpPr>
+          <p:nvPr>
+            <p:ph type="body" idx="1"/>
+          </p:nvPr>
+        </p:nvSpPr>
+        <p:spPr/>
+        <p:txBody>
+          <a:bodyPr/>
+          <a:lstStyle/>
+          <a:p>
+            <a:pPr marL="457200" indent="-457200">
+              <a:buFont typeface="Arial" panose="020B0604020202020204" pitchFamily="34" charset="0"/>
+              <a:buChar char="•"/>
+            </a:pPr>
+            <a:r>
+              <a:rPr lang="de-AT" dirty="0"/>
+              <a:t>Finalen Code für die Bildübertragung</a:t>
+            </a:r>
+          </a:p>
+          <a:p>
+            <a:endParaRPr lang="de-AT" dirty="0"/>
+          </a:p>
+          <a:p>
+            <a:pPr marL="457200" indent="-457200">
+              <a:buFont typeface="Arial" panose="020B0604020202020204" pitchFamily="34" charset="0"/>
+              <a:buChar char="•"/>
+            </a:pPr>
+            <a:r>
+              <a:rPr lang="de-AT" dirty="0"/>
+              <a:t>Verbindungsplatinen bestellen, Testen, und Einbauen </a:t>
+            </a:r>
+          </a:p>
+          <a:p>
+            <a:endParaRPr lang="de-AT" dirty="0"/>
+          </a:p>
+          <a:p>
+            <a:pPr marL="457200" indent="-457200">
+              <a:buFont typeface="Arial" panose="020B0604020202020204" pitchFamily="34" charset="0"/>
+              <a:buChar char="•"/>
+            </a:pPr>
+            <a:r>
+              <a:rPr lang="de-AT" dirty="0"/>
+              <a:t>Case Zusammenbauen und Optimieren</a:t>
+            </a:r>
+          </a:p>
+          <a:p>
+            <a:r>
+              <a:rPr lang="de-AT" dirty="0"/>
+              <a:t> </a:t>
+            </a:r>
+          </a:p>
+          <a:p>
+            <a:pPr marL="457200" indent="-457200">
+              <a:buFont typeface="Arial" panose="020B0604020202020204" pitchFamily="34" charset="0"/>
+              <a:buChar char="•"/>
+            </a:pPr>
+            <a:r>
+              <a:rPr lang="de-AT" dirty="0"/>
+              <a:t>LED-Matrix Stabilisieren und Festigen</a:t>
+            </a:r>
+          </a:p>
+        </p:txBody>
+      </p:sp>
+      <p:sp>
+        <p:nvSpPr>
+          <p:cNvPr id="4" name="Titel 3">
+            <a:extLst>
+              <a:ext uri="{FF2B5EF4-FFF2-40B4-BE49-F238E27FC236}">
+                <a16:creationId xmlns:a16="http://schemas.microsoft.com/office/drawing/2014/main" id="{F699FA7A-28CB-B166-B8BF-EF0E315053E3}"/>
+              </a:ext>
+            </a:extLst>
+          </p:cNvPr>
+          <p:cNvSpPr>
+            <a:spLocks noGrp="1"/>
+          </p:cNvSpPr>
+          <p:nvPr>
+            <p:ph type="title"/>
+          </p:nvPr>
+        </p:nvSpPr>
+        <p:spPr/>
+        <p:txBody>
+          <a:bodyPr/>
+          <a:lstStyle/>
+          <a:p>
+            <a:r>
+              <a:rPr lang="de-AT" dirty="0"/>
+              <a:t>Anstehende Punkte</a:t>
+            </a:r>
+          </a:p>
+        </p:txBody>
+      </p:sp>
+    </p:spTree>
+    <p:extLst>
+      <p:ext uri="{BB962C8B-B14F-4D97-AF65-F5344CB8AC3E}">
+        <p14:creationId xmlns:p14="http://schemas.microsoft.com/office/powerpoint/2010/main" val="465441891"/>
+      </p:ext>
+    </p:extLst>
+  </p:cSld>
+  <p:clrMapOvr>
+    <a:masterClrMapping/>
+  </p:clrMapOvr>
+</p:sld>
+</file>
+
+<file path=ppt/slides/slide16.xml><?xml version="1.0" encoding="utf-8"?>
+<p:sld xmlns:a="http://schemas.openxmlformats.org/drawingml/2006/main" xmlns:r="http://schemas.openxmlformats.org/officeDocument/2006/relationships" xmlns:p="http://schemas.openxmlformats.org/presentationml/2006/main">
+  <p:cSld>
+    <p:spTree>
+      <p:nvGrpSpPr>
+        <p:cNvPr id="1" name=""/>
+        <p:cNvGrpSpPr/>
+        <p:nvPr/>
+      </p:nvGrpSpPr>
+      <p:grpSpPr>
+        <a:xfrm>
+          <a:off x="0" y="0"/>
+          <a:ext cx="0" cy="0"/>
+          <a:chOff x="0" y="0"/>
+          <a:chExt cx="0" cy="0"/>
+        </a:xfrm>
+      </p:grpSpPr>
+      <p:pic>
+        <p:nvPicPr>
+          <p:cNvPr id="6" name="Inhaltsplatzhalter 5">
+            <a:extLst>
+              <a:ext uri="{FF2B5EF4-FFF2-40B4-BE49-F238E27FC236}">
+                <a16:creationId xmlns:a16="http://schemas.microsoft.com/office/drawing/2014/main" id="{EEB3BDCC-597A-FEB4-8BCF-6D224B7D3737}"/>
+              </a:ext>
+            </a:extLst>
+          </p:cNvPr>
+          <p:cNvPicPr>
+            <a:picLocks noGrp="1" noChangeAspect="1"/>
+          </p:cNvPicPr>
+          <p:nvPr>
+            <p:ph sz="half" idx="3"/>
+          </p:nvPr>
+        </p:nvPicPr>
+        <p:blipFill>
+          <a:blip r:embed="rId2"/>
+          <a:stretch>
+            <a:fillRect/>
+          </a:stretch>
+        </p:blipFill>
+        <p:spPr>
+          <a:xfrm>
+            <a:off x="10988154" y="1884859"/>
+            <a:ext cx="8496944" cy="7186786"/>
+          </a:xfrm>
+          <a:prstGeom prst="rect">
+            <a:avLst/>
+          </a:prstGeom>
+        </p:spPr>
+      </p:pic>
+      <p:sp>
+        <p:nvSpPr>
+          <p:cNvPr id="3" name="Textplatzhalter 2">
+            <a:extLst>
+              <a:ext uri="{FF2B5EF4-FFF2-40B4-BE49-F238E27FC236}">
+                <a16:creationId xmlns:a16="http://schemas.microsoft.com/office/drawing/2014/main" id="{FD78C6FE-9A11-F04F-DE6E-6C058D44D797}"/>
+              </a:ext>
+            </a:extLst>
+          </p:cNvPr>
+          <p:cNvSpPr>
+            <a:spLocks noGrp="1"/>
+          </p:cNvSpPr>
+          <p:nvPr>
+            <p:ph type="body" idx="1"/>
+          </p:nvPr>
+        </p:nvSpPr>
+        <p:spPr/>
+        <p:txBody>
+          <a:bodyPr/>
+          <a:lstStyle/>
+          <a:p>
+            <a:pPr marL="457200" indent="-457200">
+              <a:buFont typeface="Arial" panose="020B0604020202020204" pitchFamily="34" charset="0"/>
+              <a:buChar char="•"/>
+            </a:pPr>
+            <a:r>
+              <a:rPr lang="en-GB" dirty="0"/>
+              <a:t>OPV Schmit trigger </a:t>
+            </a:r>
+            <a:r>
+              <a:rPr lang="en-GB" dirty="0" err="1"/>
+              <a:t>Schaltung</a:t>
+            </a:r>
+            <a:endParaRPr lang="en-GB" dirty="0"/>
+          </a:p>
+          <a:p>
+            <a:pPr marL="457200" indent="-457200">
+              <a:buFont typeface="Arial" panose="020B0604020202020204" pitchFamily="34" charset="0"/>
+              <a:buChar char="•"/>
+            </a:pPr>
+            <a:r>
+              <a:rPr lang="en-GB" dirty="0"/>
+              <a:t>OPA354 -&gt; </a:t>
+            </a:r>
+            <a:r>
+              <a:rPr lang="en-GB" dirty="0" err="1"/>
+              <a:t>hohe</a:t>
+            </a:r>
+            <a:r>
+              <a:rPr lang="en-GB" dirty="0"/>
+              <a:t> </a:t>
+            </a:r>
+            <a:r>
+              <a:rPr lang="en-GB" dirty="0" err="1"/>
+              <a:t>Frequenz</a:t>
+            </a:r>
+            <a:r>
+              <a:rPr lang="en-GB" dirty="0"/>
+              <a:t> &amp; Slew Rate</a:t>
+            </a:r>
+          </a:p>
+          <a:p>
+            <a:pPr marL="457200" indent="-457200">
+              <a:buFont typeface="Arial" panose="020B0604020202020204" pitchFamily="34" charset="0"/>
+              <a:buChar char="•"/>
+            </a:pPr>
+            <a:r>
+              <a:rPr lang="en-GB" dirty="0"/>
+              <a:t>Signal (</a:t>
+            </a:r>
+            <a:r>
+              <a:rPr lang="en-GB" dirty="0" err="1"/>
+              <a:t>blau</a:t>
+            </a:r>
+            <a:r>
+              <a:rPr lang="en-GB" dirty="0"/>
+              <a:t>) </a:t>
+            </a:r>
+            <a:r>
+              <a:rPr lang="en-GB" dirty="0" err="1"/>
+              <a:t>wird</a:t>
+            </a:r>
+            <a:r>
+              <a:rPr lang="en-GB" dirty="0"/>
+              <a:t> </a:t>
+            </a:r>
+            <a:r>
+              <a:rPr lang="en-GB" dirty="0" err="1"/>
+              <a:t>repariert</a:t>
+            </a:r>
+            <a:endParaRPr lang="en-GB" dirty="0"/>
+          </a:p>
+          <a:p>
+            <a:endParaRPr lang="de-AT" dirty="0"/>
+          </a:p>
+        </p:txBody>
+      </p:sp>
+      <p:sp>
+        <p:nvSpPr>
+          <p:cNvPr id="4" name="Titel 3">
+            <a:extLst>
+              <a:ext uri="{FF2B5EF4-FFF2-40B4-BE49-F238E27FC236}">
+                <a16:creationId xmlns:a16="http://schemas.microsoft.com/office/drawing/2014/main" id="{9817CC6F-DB7F-3797-D3F2-DB9B3193640E}"/>
+              </a:ext>
+            </a:extLst>
+          </p:cNvPr>
+          <p:cNvSpPr>
+            <a:spLocks noGrp="1"/>
+          </p:cNvSpPr>
+          <p:nvPr>
+            <p:ph type="title"/>
+          </p:nvPr>
+        </p:nvSpPr>
+        <p:spPr/>
+        <p:txBody>
+          <a:bodyPr/>
+          <a:lstStyle/>
+          <a:p>
+            <a:r>
+              <a:rPr lang="en-GB" dirty="0"/>
+              <a:t>Led Matrix</a:t>
+            </a:r>
+            <a:endParaRPr lang="de-AT" dirty="0"/>
+          </a:p>
+        </p:txBody>
+      </p:sp>
+      <p:pic>
+        <p:nvPicPr>
+          <p:cNvPr id="8" name="Grafik 7">
+            <a:extLst>
+              <a:ext uri="{FF2B5EF4-FFF2-40B4-BE49-F238E27FC236}">
+                <a16:creationId xmlns:a16="http://schemas.microsoft.com/office/drawing/2014/main" id="{D2D132EC-A0F5-D82A-0906-DDE41F5E37D2}"/>
+              </a:ext>
+            </a:extLst>
+          </p:cNvPr>
+          <p:cNvPicPr>
+            <a:picLocks noChangeAspect="1"/>
+          </p:cNvPicPr>
+          <p:nvPr/>
+        </p:nvPicPr>
+        <p:blipFill>
+          <a:blip r:embed="rId3"/>
+          <a:stretch>
+            <a:fillRect/>
+          </a:stretch>
+        </p:blipFill>
+        <p:spPr>
+          <a:xfrm>
+            <a:off x="812331" y="4909195"/>
+            <a:ext cx="9576918" cy="5941885"/>
+          </a:xfrm>
+          <a:prstGeom prst="rect">
+            <a:avLst/>
+          </a:prstGeom>
+        </p:spPr>
+      </p:pic>
+    </p:spTree>
+    <p:extLst>
+      <p:ext uri="{BB962C8B-B14F-4D97-AF65-F5344CB8AC3E}">
+        <p14:creationId xmlns:p14="http://schemas.microsoft.com/office/powerpoint/2010/main" val="1340584775"/>
+      </p:ext>
+    </p:extLst>
+  </p:cSld>
+  <p:clrMapOvr>
+    <a:masterClrMapping/>
+  </p:clrMapOvr>
+</p:sld>
+</file>
+
+<file path=ppt/slides/slide17.xml><?xml version="1.0" encoding="utf-8"?>
+<p:sld xmlns:a="http://schemas.openxmlformats.org/drawingml/2006/main" xmlns:r="http://schemas.openxmlformats.org/officeDocument/2006/relationships" xmlns:p="http://schemas.openxmlformats.org/presentationml/2006/main">
+  <p:cSld>
+    <p:spTree>
+      <p:nvGrpSpPr>
+        <p:cNvPr id="1" name=""/>
+        <p:cNvGrpSpPr/>
+        <p:nvPr/>
+      </p:nvGrpSpPr>
+      <p:grpSpPr>
+        <a:xfrm>
+          <a:off x="0" y="0"/>
+          <a:ext cx="0" cy="0"/>
+          <a:chOff x="0" y="0"/>
+          <a:chExt cx="0" cy="0"/>
+        </a:xfrm>
+      </p:grpSpPr>
+      <p:sp>
+        <p:nvSpPr>
+          <p:cNvPr id="2" name="Titel 1">
+            <a:extLst>
+              <a:ext uri="{FF2B5EF4-FFF2-40B4-BE49-F238E27FC236}">
+                <a16:creationId xmlns:a16="http://schemas.microsoft.com/office/drawing/2014/main" id="{28AFEFF8-C8D5-CE39-83AB-9C08C0307D25}"/>
+              </a:ext>
+            </a:extLst>
+          </p:cNvPr>
+          <p:cNvSpPr>
+            <a:spLocks noGrp="1"/>
+          </p:cNvSpPr>
+          <p:nvPr>
+            <p:ph type="title"/>
+          </p:nvPr>
+        </p:nvSpPr>
+        <p:spPr/>
+        <p:txBody>
+          <a:bodyPr/>
+          <a:lstStyle/>
+          <a:p>
+            <a:r>
+              <a:rPr lang="en-GB" dirty="0"/>
+              <a:t>Proof of Concept</a:t>
+            </a:r>
+            <a:endParaRPr lang="de-AT" dirty="0"/>
+          </a:p>
+        </p:txBody>
+      </p:sp>
+      <p:sp>
+        <p:nvSpPr>
+          <p:cNvPr id="3" name="Bildplatzhalter 2">
+            <a:extLst>
+              <a:ext uri="{FF2B5EF4-FFF2-40B4-BE49-F238E27FC236}">
+                <a16:creationId xmlns:a16="http://schemas.microsoft.com/office/drawing/2014/main" id="{0F2DEAF0-5030-0AB9-7D02-7F042F24CF1B}"/>
+              </a:ext>
+            </a:extLst>
+          </p:cNvPr>
+          <p:cNvSpPr>
+            <a:spLocks noGrp="1"/>
+          </p:cNvSpPr>
+          <p:nvPr>
+            <p:ph type="pic" sz="quarter" idx="10"/>
+          </p:nvPr>
+        </p:nvSpPr>
+        <p:spPr/>
+        <p:txBody>
+          <a:bodyPr/>
+          <a:lstStyle/>
+          <a:p>
+            <a:endParaRPr lang="de-AT"/>
+          </a:p>
+        </p:txBody>
+      </p:sp>
+      <p:pic>
+        <p:nvPicPr>
+          <p:cNvPr id="4" name="WhatsApp Video 2026-03-04 at 15.52.23">
+            <a:hlinkClick r:id="" action="ppaction://media"/>
+            <a:extLst>
+              <a:ext uri="{FF2B5EF4-FFF2-40B4-BE49-F238E27FC236}">
+                <a16:creationId xmlns:a16="http://schemas.microsoft.com/office/drawing/2014/main" id="{1B1497BF-B7AB-EAC3-8C48-39EA1D1BFE7E}"/>
+              </a:ext>
+            </a:extLst>
+          </p:cNvPr>
+          <p:cNvPicPr>
+            <a:picLocks noChangeAspect="1"/>
+          </p:cNvPicPr>
+          <p:nvPr>
+            <a:videoFile r:link="rId2"/>
+            <p:extLst>
+              <p:ext uri="{DAA4B4D4-6D71-4841-9C94-3DE7FCFB9230}">
+                <p14:media xmlns:p14="http://schemas.microsoft.com/office/powerpoint/2010/main" r:embed="rId1"/>
+              </p:ext>
+            </p:extLst>
+          </p:nvPr>
+        </p:nvPicPr>
+        <p:blipFill>
+          <a:blip r:embed="rId4"/>
+          <a:stretch>
+            <a:fillRect/>
+          </a:stretch>
+        </p:blipFill>
+        <p:spPr>
+          <a:xfrm>
+            <a:off x="7171730" y="1955160"/>
+            <a:ext cx="5112568" cy="9031316"/>
+          </a:xfrm>
+          <a:prstGeom prst="rect">
+            <a:avLst/>
+          </a:prstGeom>
+        </p:spPr>
+      </p:pic>
+    </p:spTree>
+    <p:extLst>
+      <p:ext uri="{BB962C8B-B14F-4D97-AF65-F5344CB8AC3E}">
+        <p14:creationId xmlns:p14="http://schemas.microsoft.com/office/powerpoint/2010/main" val="4172356551"/>
+      </p:ext>
+    </p:extLst>
+  </p:cSld>
+  <p:clrMapOvr>
+    <a:masterClrMapping/>
+  </p:clrMapOvr>
+  <p:timing>
+    <p:tnLst>
+      <p:par>
+        <p:cTn id="1" dur="indefinite" restart="never" nodeType="tmRoot">
+          <p:childTnLst>
+            <p:seq concurrent="1" nextAc="seek">
+              <p:cTn id="2" dur="indefinite" nodeType="mainSeq">
+                <p:childTnLst>
+                  <p:par>
+                    <p:cTn id="3" fill="hold">
+                      <p:stCondLst>
+                        <p:cond delay="indefinite"/>
+                      </p:stCondLst>
+                      <p:childTnLst>
+                        <p:par>
+                          <p:cTn id="4" fill="hold">
+                            <p:stCondLst>
+                              <p:cond delay="0"/>
+                            </p:stCondLst>
+                            <p:childTnLst>
+                              <p:par>
+                                <p:cTn id="5" presetID="1" presetClass="mediacall" presetSubtype="0" fill="hold" nodeType="clickEffect">
+                                  <p:stCondLst>
+                                    <p:cond delay="0"/>
+                                  </p:stCondLst>
+                                  <p:childTnLst>
+                                    <p:cmd type="call" cmd="playFrom(0.0)">
+                                      <p:cBhvr>
+                                        <p:cTn id="6" dur="11284" fill="hold"/>
+                                        <p:tgtEl>
+                                          <p:spTgt spid="4"/>
+                                        </p:tgtEl>
+                                      </p:cBhvr>
+                                    </p:cmd>
+                                  </p:childTnLst>
+                                </p:cTn>
+                              </p:par>
+                            </p:childTnLst>
+                          </p:cTn>
+                        </p:par>
+                      </p:childTnLst>
+                    </p:cTn>
+                  </p:par>
+                </p:childTnLst>
+              </p:cTn>
+              <p:prevCondLst>
+                <p:cond evt="onPrev" delay="0">
+                  <p:tgtEl>
+                    <p:sldTgt/>
+                  </p:tgtEl>
+                </p:cond>
+              </p:prevCondLst>
+              <p:nextCondLst>
+                <p:cond evt="onNext" delay="0">
+                  <p:tgtEl>
+                    <p:sldTgt/>
+                  </p:tgtEl>
+                </p:cond>
+              </p:nextCondLst>
+            </p:seq>
+            <p:video>
+              <p:cMediaNode vol="80000">
+                <p:cTn id="7" fill="hold" display="0">
+                  <p:stCondLst>
+                    <p:cond delay="indefinite"/>
+                  </p:stCondLst>
+                </p:cTn>
+                <p:tgtEl>
+                  <p:spTgt spid="4"/>
+                </p:tgtEl>
+              </p:cMediaNode>
+            </p:video>
+            <p:seq concurrent="1" nextAc="seek">
+              <p:cTn id="8" restart="whenNotActive" fill="hold" evtFilter="cancelBubble" nodeType="interactiveSeq">
+                <p:stCondLst>
+                  <p:cond evt="onClick" delay="0">
+                    <p:tgtEl>
+                      <p:spTgt spid="4"/>
+                    </p:tgtEl>
+                  </p:cond>
+                </p:stCondLst>
+                <p:endSync evt="end" delay="0">
+                  <p:rtn val="all"/>
+                </p:endSync>
+                <p:childTnLst>
+                  <p:par>
+                    <p:cTn id="9" fill="hold">
+                      <p:stCondLst>
+                        <p:cond delay="0"/>
+                      </p:stCondLst>
+                      <p:childTnLst>
+                        <p:par>
+                          <p:cTn id="10" fill="hold">
+                            <p:stCondLst>
+                              <p:cond delay="0"/>
+                            </p:stCondLst>
+                            <p:childTnLst>
+                              <p:par>
+                                <p:cTn id="11" presetID="2" presetClass="mediacall" presetSubtype="0" fill="hold" nodeType="clickEffect">
+                                  <p:stCondLst>
+                                    <p:cond delay="0"/>
+                                  </p:stCondLst>
+                                  <p:childTnLst>
+                                    <p:cmd type="call" cmd="togglePause">
+                                      <p:cBhvr>
+                                        <p:cTn id="12" dur="1" fill="hold"/>
+                                        <p:tgtEl>
+                                          <p:spTgt spid="4"/>
+                                        </p:tgtEl>
+                                      </p:cBhvr>
+                                    </p:cmd>
+                                  </p:childTnLst>
+                                </p:cTn>
+                              </p:par>
+                            </p:childTnLst>
+                          </p:cTn>
+                        </p:par>
+                      </p:childTnLst>
+                    </p:cTn>
+                  </p:par>
+                </p:childTnLst>
+              </p:cTn>
+              <p:nextCondLst>
+                <p:cond evt="onClick" delay="0">
+                  <p:tgtEl>
+                    <p:spTgt spid="4"/>
+                  </p:tgtEl>
+                </p:cond>
+              </p:nextCondLst>
+            </p:seq>
+          </p:childTnLst>
+        </p:cTn>
+      </p:par>
+    </p:tnLst>
+  </p:timing>
+</p:sld>
+</file>
+
+<file path=ppt/slides/slide18.xml><?xml version="1.0" encoding="utf-8"?>
+<p:sld xmlns:a="http://schemas.openxmlformats.org/drawingml/2006/main" xmlns:r="http://schemas.openxmlformats.org/officeDocument/2006/relationships" xmlns:p="http://schemas.openxmlformats.org/presentationml/2006/main">
+  <p:cSld>
+    <p:spTree>
+      <p:nvGrpSpPr>
+        <p:cNvPr id="1" name=""/>
+        <p:cNvGrpSpPr/>
+        <p:nvPr/>
+      </p:nvGrpSpPr>
+      <p:grpSpPr>
+        <a:xfrm>
+          <a:off x="0" y="0"/>
+          <a:ext cx="0" cy="0"/>
+          <a:chOff x="0" y="0"/>
+          <a:chExt cx="0" cy="0"/>
+        </a:xfrm>
+      </p:grpSpPr>
+      <p:sp>
+        <p:nvSpPr>
+          <p:cNvPr id="2" name="Titel 1">
+            <a:extLst>
+              <a:ext uri="{FF2B5EF4-FFF2-40B4-BE49-F238E27FC236}">
+                <a16:creationId xmlns:a16="http://schemas.microsoft.com/office/drawing/2014/main" id="{F59C0994-73BF-6DDB-5C09-131340C35FB7}"/>
+              </a:ext>
+            </a:extLst>
+          </p:cNvPr>
+          <p:cNvSpPr>
+            <a:spLocks noGrp="1"/>
+          </p:cNvSpPr>
+          <p:nvPr>
+            <p:ph type="title"/>
+          </p:nvPr>
+        </p:nvSpPr>
+        <p:spPr/>
+        <p:txBody>
+          <a:bodyPr/>
+          <a:lstStyle/>
+          <a:p>
+            <a:r>
+              <a:rPr lang="en-GB" dirty="0" err="1"/>
+              <a:t>Probleme</a:t>
+            </a:r>
+            <a:endParaRPr lang="de-AT" dirty="0"/>
+          </a:p>
+        </p:txBody>
+      </p:sp>
+      <p:sp>
+        <p:nvSpPr>
+          <p:cNvPr id="3" name="Textplatzhalter 2">
+            <a:extLst>
+              <a:ext uri="{FF2B5EF4-FFF2-40B4-BE49-F238E27FC236}">
+                <a16:creationId xmlns:a16="http://schemas.microsoft.com/office/drawing/2014/main" id="{343D1CAF-6AF6-8017-2556-3FCC1EEA6336}"/>
+              </a:ext>
+            </a:extLst>
+          </p:cNvPr>
+          <p:cNvSpPr>
+            <a:spLocks noGrp="1"/>
+          </p:cNvSpPr>
+          <p:nvPr>
+            <p:ph type="body" idx="1"/>
+          </p:nvPr>
+        </p:nvSpPr>
+        <p:spPr/>
+        <p:txBody>
+          <a:bodyPr/>
+          <a:lstStyle/>
+          <a:p>
+            <a:r>
+              <a:rPr lang="en-GB" b="1" dirty="0" err="1"/>
+              <a:t>Anfänglich</a:t>
+            </a:r>
+            <a:r>
+              <a:rPr lang="en-GB" b="1" dirty="0"/>
+              <a:t>:</a:t>
+            </a:r>
+          </a:p>
+          <a:p>
+            <a:pPr marL="457200" indent="-457200">
+              <a:buFont typeface="Arial" panose="020B0604020202020204" pitchFamily="34" charset="0"/>
+              <a:buChar char="•"/>
+            </a:pPr>
+            <a:r>
+              <a:rPr lang="de-AT" dirty="0"/>
+              <a:t>Eine stabile Silhouette erstellen</a:t>
+            </a:r>
+          </a:p>
+          <a:p>
+            <a:pPr marL="457200" indent="-457200">
+              <a:buFont typeface="Arial" panose="020B0604020202020204" pitchFamily="34" charset="0"/>
+              <a:buChar char="•"/>
+            </a:pPr>
+            <a:r>
+              <a:rPr lang="de-AT" dirty="0"/>
+              <a:t>Eine Case Idee</a:t>
+            </a:r>
+          </a:p>
+          <a:p>
+            <a:pPr marL="457200" indent="-457200">
+              <a:buFont typeface="Arial" panose="020B0604020202020204" pitchFamily="34" charset="0"/>
+              <a:buChar char="•"/>
+            </a:pPr>
+            <a:endParaRPr lang="de-AT" dirty="0"/>
+          </a:p>
+          <a:p>
+            <a:pPr marL="457200" indent="-457200">
+              <a:buFont typeface="Arial" panose="020B0604020202020204" pitchFamily="34" charset="0"/>
+              <a:buChar char="•"/>
+            </a:pPr>
+            <a:endParaRPr lang="de-AT" dirty="0"/>
+          </a:p>
+          <a:p>
+            <a:pPr marL="457200" indent="-457200">
+              <a:buFont typeface="Arial" panose="020B0604020202020204" pitchFamily="34" charset="0"/>
+              <a:buChar char="•"/>
+            </a:pPr>
+            <a:endParaRPr lang="de-AT" b="1" dirty="0"/>
+          </a:p>
+          <a:p>
+            <a:r>
+              <a:rPr lang="de-AT" b="1" dirty="0"/>
+              <a:t>Zurzeit:</a:t>
+            </a:r>
+          </a:p>
+          <a:p>
+            <a:pPr marL="457200" indent="-457200">
+              <a:buFont typeface="Arial" panose="020B0604020202020204" pitchFamily="34" charset="0"/>
+              <a:buChar char="•"/>
+            </a:pPr>
+            <a:r>
+              <a:rPr lang="de-AT" dirty="0"/>
+              <a:t>Alle 9 Reihen der Led anzusteuern</a:t>
+            </a:r>
+          </a:p>
+          <a:p>
+            <a:pPr marL="457200" indent="-457200">
+              <a:buFont typeface="Arial" panose="020B0604020202020204" pitchFamily="34" charset="0"/>
+              <a:buChar char="•"/>
+            </a:pPr>
+            <a:r>
+              <a:rPr lang="de-AT" dirty="0"/>
+              <a:t>Die Finger / Hand präzise anzeigen</a:t>
+            </a:r>
+            <a:endParaRPr lang="de-AT" b="1" dirty="0"/>
+          </a:p>
+          <a:p>
+            <a:pPr marL="457200" indent="-457200">
+              <a:buFont typeface="Arial" panose="020B0604020202020204" pitchFamily="34" charset="0"/>
+              <a:buChar char="•"/>
+            </a:pPr>
+            <a:endParaRPr lang="de-AT" dirty="0"/>
+          </a:p>
+        </p:txBody>
+      </p:sp>
+    </p:spTree>
+    <p:extLst>
+      <p:ext uri="{BB962C8B-B14F-4D97-AF65-F5344CB8AC3E}">
+        <p14:creationId xmlns:p14="http://schemas.microsoft.com/office/powerpoint/2010/main" val="1890933088"/>
+      </p:ext>
+    </p:extLst>
+  </p:cSld>
+  <p:clrMapOvr>
+    <a:masterClrMapping/>
+  </p:clrMapOvr>
+</p:sld>
+</file>
+
+<file path=ppt/slides/slide19.xml><?xml version="1.0" encoding="utf-8"?>
+<p:sld xmlns:a="http://schemas.openxmlformats.org/drawingml/2006/main" xmlns:r="http://schemas.openxmlformats.org/officeDocument/2006/relationships" xmlns:p="http://schemas.openxmlformats.org/presentationml/2006/main">
+  <p:cSld>
+    <p:spTree>
+      <p:nvGrpSpPr>
+        <p:cNvPr id="1" name=""/>
+        <p:cNvGrpSpPr/>
+        <p:nvPr/>
+      </p:nvGrpSpPr>
+      <p:grpSpPr>
+        <a:xfrm>
+          <a:off x="0" y="0"/>
+          <a:ext cx="0" cy="0"/>
+          <a:chOff x="0" y="0"/>
+          <a:chExt cx="0" cy="0"/>
+        </a:xfrm>
+      </p:grpSpPr>
+      <p:sp>
+        <p:nvSpPr>
+          <p:cNvPr id="2" name="Titel 1">
+            <a:extLst>
+              <a:ext uri="{FF2B5EF4-FFF2-40B4-BE49-F238E27FC236}">
+                <a16:creationId xmlns:a16="http://schemas.microsoft.com/office/drawing/2014/main" id="{E75308D1-7295-43AD-FE51-AF9697D1F362}"/>
+              </a:ext>
+            </a:extLst>
+          </p:cNvPr>
+          <p:cNvSpPr>
+            <a:spLocks noGrp="1"/>
+          </p:cNvSpPr>
+          <p:nvPr>
+            <p:ph type="title"/>
+          </p:nvPr>
+        </p:nvSpPr>
+        <p:spPr/>
+        <p:txBody>
+          <a:bodyPr/>
+          <a:lstStyle/>
+          <a:p>
+            <a:r>
+              <a:rPr lang="en-GB" dirty="0" err="1"/>
+              <a:t>Besonders</a:t>
+            </a:r>
+            <a:r>
+              <a:rPr lang="en-GB" dirty="0"/>
+              <a:t> </a:t>
+            </a:r>
+            <a:r>
+              <a:rPr lang="en-GB" dirty="0" err="1"/>
+              <a:t>Aufwendig</a:t>
+            </a:r>
+            <a:endParaRPr lang="de-AT" dirty="0"/>
+          </a:p>
+        </p:txBody>
+      </p:sp>
+      <p:sp>
+        <p:nvSpPr>
+          <p:cNvPr id="3" name="Textplatzhalter 2">
+            <a:extLst>
+              <a:ext uri="{FF2B5EF4-FFF2-40B4-BE49-F238E27FC236}">
+                <a16:creationId xmlns:a16="http://schemas.microsoft.com/office/drawing/2014/main" id="{8A0FFE43-28B7-84D9-750A-9CAB7F01A4A0}"/>
+              </a:ext>
+            </a:extLst>
+          </p:cNvPr>
+          <p:cNvSpPr>
+            <a:spLocks noGrp="1"/>
+          </p:cNvSpPr>
+          <p:nvPr>
+            <p:ph type="body" idx="1"/>
+          </p:nvPr>
+        </p:nvSpPr>
+        <p:spPr/>
+        <p:txBody>
+          <a:bodyPr/>
+          <a:lstStyle/>
+          <a:p>
+            <a:pPr marL="457200" indent="-457200">
+              <a:buFont typeface="Arial" panose="020B0604020202020204" pitchFamily="34" charset="0"/>
+              <a:buChar char="•"/>
+            </a:pPr>
+            <a:r>
+              <a:rPr lang="en-GB" dirty="0"/>
+              <a:t>Stabile Silhouette</a:t>
+            </a:r>
+          </a:p>
+          <a:p>
+            <a:pPr marL="457200" indent="-457200">
+              <a:buFont typeface="Arial" panose="020B0604020202020204" pitchFamily="34" charset="0"/>
+              <a:buChar char="•"/>
+            </a:pPr>
+            <a:endParaRPr lang="en-GB" dirty="0"/>
+          </a:p>
+          <a:p>
+            <a:pPr marL="457200" indent="-457200">
+              <a:buFont typeface="Arial" panose="020B0604020202020204" pitchFamily="34" charset="0"/>
+              <a:buChar char="•"/>
+            </a:pPr>
+            <a:r>
+              <a:rPr lang="en-GB" dirty="0"/>
+              <a:t>Parameter</a:t>
+            </a:r>
+          </a:p>
+          <a:p>
+            <a:pPr marL="457200" indent="-457200">
+              <a:buFont typeface="Arial" panose="020B0604020202020204" pitchFamily="34" charset="0"/>
+              <a:buChar char="•"/>
+            </a:pPr>
+            <a:endParaRPr lang="en-GB" dirty="0"/>
+          </a:p>
+          <a:p>
+            <a:pPr marL="457200" indent="-457200">
+              <a:buFont typeface="Arial" panose="020B0604020202020204" pitchFamily="34" charset="0"/>
+              <a:buChar char="•"/>
+            </a:pPr>
+            <a:r>
+              <a:rPr lang="en-GB" dirty="0"/>
+              <a:t>Led Module </a:t>
+            </a:r>
+            <a:r>
+              <a:rPr lang="en-GB" dirty="0" err="1"/>
+              <a:t>vorbereiten</a:t>
+            </a:r>
+            <a:endParaRPr lang="en-GB" dirty="0"/>
+          </a:p>
+          <a:p>
+            <a:pPr marL="457200" indent="-457200">
+              <a:buFont typeface="Arial" panose="020B0604020202020204" pitchFamily="34" charset="0"/>
+              <a:buChar char="•"/>
+            </a:pPr>
+            <a:endParaRPr lang="en-GB" dirty="0"/>
+          </a:p>
+          <a:p>
+            <a:pPr marL="457200" indent="-457200">
+              <a:buFont typeface="Arial" panose="020B0604020202020204" pitchFamily="34" charset="0"/>
+              <a:buChar char="•"/>
+            </a:pPr>
+            <a:r>
+              <a:rPr lang="en-GB" dirty="0" err="1"/>
+              <a:t>Bauteile</a:t>
+            </a:r>
+            <a:r>
+              <a:rPr lang="en-GB" dirty="0"/>
+              <a:t> </a:t>
+            </a:r>
+            <a:r>
+              <a:rPr lang="en-GB" dirty="0" err="1"/>
+              <a:t>besorgen</a:t>
+            </a:r>
+            <a:r>
+              <a:rPr lang="en-GB" dirty="0"/>
+              <a:t> </a:t>
+            </a:r>
+          </a:p>
+          <a:p>
+            <a:endParaRPr lang="en-GB" dirty="0"/>
+          </a:p>
+        </p:txBody>
+      </p:sp>
+    </p:spTree>
+    <p:extLst>
+      <p:ext uri="{BB962C8B-B14F-4D97-AF65-F5344CB8AC3E}">
+        <p14:creationId xmlns:p14="http://schemas.microsoft.com/office/powerpoint/2010/main" val="3130861516"/>
+      </p:ext>
+    </p:extLst>
+  </p:cSld>
+  <p:clrMapOvr>
+    <a:masterClrMapping/>
+  </p:clrMapOvr>
+</p:sld>
+</file>
+
 <file path=ppt/slides/slide2.xml><?xml version="1.0" encoding="utf-8"?>
 <p:sld xmlns:a="http://schemas.openxmlformats.org/drawingml/2006/main" xmlns:r="http://schemas.openxmlformats.org/officeDocument/2006/relationships" xmlns:p="http://schemas.openxmlformats.org/presentationml/2006/main">
   <p:cSld>
@@ -29498,120 +31895,322 @@
           <a:bodyPr/>
           <a:lstStyle/>
           <a:p>
+            <a:pPr marL="457200" indent="-457200">
+              <a:buFont typeface="Arial" panose="020B0604020202020204" pitchFamily="34" charset="0"/>
+              <a:buChar char="•"/>
+            </a:pPr>
             <a:r>
-              <a:rPr lang="de-AT" dirty="0"/>
-              <a:t>Echtzeit-Silhouetten-Darstellung von Personen auf einer LED-Matrix</a:t>
+              <a:rPr lang="en-GB" dirty="0"/>
+              <a:t>Raspberry Pi Camera</a:t>
             </a:r>
           </a:p>
           <a:p>
+            <a:pPr marL="457200" indent="-457200">
+              <a:buFont typeface="Arial" panose="020B0604020202020204" pitchFamily="34" charset="0"/>
+              <a:buChar char="•"/>
+            </a:pPr>
+            <a:r>
+              <a:rPr lang="de-AT" dirty="0"/>
+              <a:t>Silhouette erstellen</a:t>
+            </a:r>
+          </a:p>
+          <a:p>
+            <a:pPr marL="457200" indent="-457200">
+              <a:buFont typeface="Arial" panose="020B0604020202020204" pitchFamily="34" charset="0"/>
+              <a:buChar char="•"/>
+            </a:pPr>
+            <a:r>
+              <a:rPr lang="de-AT" dirty="0"/>
+              <a:t>Auf die LEDs Skalieren</a:t>
+            </a:r>
+          </a:p>
+          <a:p>
+            <a:pPr marL="457200" indent="-457200">
+              <a:buFont typeface="Arial" panose="020B0604020202020204" pitchFamily="34" charset="0"/>
+              <a:buChar char="•"/>
+            </a:pPr>
+            <a:r>
+              <a:rPr lang="de-AT" dirty="0"/>
+              <a:t>Anzeige</a:t>
+            </a:r>
+          </a:p>
+        </p:txBody>
+      </p:sp>
+      <p:pic>
+        <p:nvPicPr>
+          <p:cNvPr id="9" name="Grafik 8">
+            <a:extLst>
+              <a:ext uri="{FF2B5EF4-FFF2-40B4-BE49-F238E27FC236}">
+                <a16:creationId xmlns:a16="http://schemas.microsoft.com/office/drawing/2014/main" id="{84F44C3E-7BD9-55AC-A74E-B91BCBBCC616}"/>
+              </a:ext>
+            </a:extLst>
+          </p:cNvPr>
+          <p:cNvPicPr>
+            <a:picLocks noChangeAspect="1"/>
+          </p:cNvPicPr>
+          <p:nvPr/>
+        </p:nvPicPr>
+        <p:blipFill>
+          <a:blip r:embed="rId2"/>
+          <a:stretch>
+            <a:fillRect/>
+          </a:stretch>
+        </p:blipFill>
+        <p:spPr>
+          <a:xfrm>
+            <a:off x="619002" y="5650345"/>
+            <a:ext cx="18866096" cy="2732750"/>
+          </a:xfrm>
+          <a:prstGeom prst="rect">
+            <a:avLst/>
+          </a:prstGeom>
+        </p:spPr>
+      </p:pic>
+    </p:spTree>
+    <p:extLst>
+      <p:ext uri="{BB962C8B-B14F-4D97-AF65-F5344CB8AC3E}">
+        <p14:creationId xmlns:p14="http://schemas.microsoft.com/office/powerpoint/2010/main" val="2583020303"/>
+      </p:ext>
+    </p:extLst>
+  </p:cSld>
+  <p:clrMapOvr>
+    <a:masterClrMapping/>
+  </p:clrMapOvr>
+</p:sld>
+</file>
+
+<file path=ppt/slides/slide20.xml><?xml version="1.0" encoding="utf-8"?>
+<p:sld xmlns:a="http://schemas.openxmlformats.org/drawingml/2006/main" xmlns:r="http://schemas.openxmlformats.org/officeDocument/2006/relationships" xmlns:p="http://schemas.openxmlformats.org/presentationml/2006/main">
+  <p:cSld>
+    <p:spTree>
+      <p:nvGrpSpPr>
+        <p:cNvPr id="1" name=""/>
+        <p:cNvGrpSpPr/>
+        <p:nvPr/>
+      </p:nvGrpSpPr>
+      <p:grpSpPr>
+        <a:xfrm>
+          <a:off x="0" y="0"/>
+          <a:ext cx="0" cy="0"/>
+          <a:chOff x="0" y="0"/>
+          <a:chExt cx="0" cy="0"/>
+        </a:xfrm>
+      </p:grpSpPr>
+      <p:sp>
+        <p:nvSpPr>
+          <p:cNvPr id="2" name="Titel 1">
+            <a:extLst>
+              <a:ext uri="{FF2B5EF4-FFF2-40B4-BE49-F238E27FC236}">
+                <a16:creationId xmlns:a16="http://schemas.microsoft.com/office/drawing/2014/main" id="{B662FD61-4DDB-5C5C-0E59-93B24C575EF8}"/>
+              </a:ext>
+            </a:extLst>
+          </p:cNvPr>
+          <p:cNvSpPr>
+            <a:spLocks noGrp="1"/>
+          </p:cNvSpPr>
+          <p:nvPr>
+            <p:ph type="title"/>
+          </p:nvPr>
+        </p:nvSpPr>
+        <p:spPr/>
+        <p:txBody>
+          <a:bodyPr/>
+          <a:lstStyle/>
+          <a:p>
+            <a:r>
+              <a:rPr lang="en-GB" dirty="0"/>
+              <a:t>Aus </a:t>
+            </a:r>
+            <a:r>
+              <a:rPr lang="en-GB" dirty="0" err="1"/>
+              <a:t>dem</a:t>
+            </a:r>
+            <a:r>
+              <a:rPr lang="en-GB" dirty="0"/>
+              <a:t> </a:t>
+            </a:r>
+            <a:r>
+              <a:rPr lang="en-GB" dirty="0" err="1"/>
+              <a:t>Unterricht</a:t>
+            </a:r>
+            <a:r>
+              <a:rPr lang="en-GB" dirty="0"/>
+              <a:t> </a:t>
+            </a:r>
+            <a:r>
+              <a:rPr lang="en-GB" dirty="0" err="1"/>
+              <a:t>gelernt</a:t>
+            </a:r>
             <a:endParaRPr lang="de-AT" dirty="0"/>
+          </a:p>
+        </p:txBody>
+      </p:sp>
+      <p:sp>
+        <p:nvSpPr>
+          <p:cNvPr id="3" name="Textplatzhalter 2">
+            <a:extLst>
+              <a:ext uri="{FF2B5EF4-FFF2-40B4-BE49-F238E27FC236}">
+                <a16:creationId xmlns:a16="http://schemas.microsoft.com/office/drawing/2014/main" id="{453E415F-9097-F982-70D6-F2B46AF6CC03}"/>
+              </a:ext>
+            </a:extLst>
+          </p:cNvPr>
+          <p:cNvSpPr>
+            <a:spLocks noGrp="1"/>
+          </p:cNvSpPr>
+          <p:nvPr>
+            <p:ph type="body" idx="1"/>
+          </p:nvPr>
+        </p:nvSpPr>
+        <p:spPr/>
+        <p:txBody>
+          <a:bodyPr/>
+          <a:lstStyle/>
+          <a:p>
+            <a:r>
+              <a:rPr lang="en-GB" dirty="0"/>
+              <a:t>HWE / DIC: Hardware Debugging (</a:t>
+            </a:r>
+            <a:r>
+              <a:rPr lang="en-GB" dirty="0" err="1"/>
+              <a:t>Zwischenplatinen</a:t>
+            </a:r>
+            <a:r>
+              <a:rPr lang="en-GB" dirty="0"/>
+              <a:t>, OPV)</a:t>
+            </a:r>
+          </a:p>
+          <a:p>
+            <a:endParaRPr lang="en-GB" dirty="0"/>
           </a:p>
           <a:p>
             <a:r>
-              <a:rPr lang="de-AT" b="1" dirty="0"/>
-              <a:t>Komponenten</a:t>
+              <a:rPr lang="en-GB" dirty="0"/>
+              <a:t>DIC: Filter </a:t>
+            </a:r>
+            <a:r>
+              <a:rPr lang="en-GB" dirty="0" err="1"/>
+              <a:t>wie</a:t>
+            </a:r>
+            <a:r>
+              <a:rPr lang="en-GB" dirty="0"/>
+              <a:t> Erode und Dilate </a:t>
+            </a:r>
+            <a:r>
+              <a:rPr lang="en-GB" dirty="0" err="1"/>
+              <a:t>anwenden</a:t>
+            </a:r>
+            <a:r>
+              <a:rPr lang="en-GB" dirty="0"/>
+              <a:t> (</a:t>
+            </a:r>
+            <a:r>
+              <a:rPr lang="en-GB" dirty="0" err="1"/>
+              <a:t>Personenerfassung</a:t>
+            </a:r>
+            <a:r>
+              <a:rPr lang="en-GB" dirty="0"/>
+              <a:t>) </a:t>
             </a:r>
           </a:p>
           <a:p>
-            <a:r>
-              <a:rPr lang="de-AT" sz="2800" b="1" dirty="0"/>
-              <a:t>Hardware:</a:t>
-            </a:r>
-            <a:r>
-              <a:rPr lang="de-AT" sz="2800" dirty="0"/>
-              <a:t> Raspberry Pi + LED-Matrix </a:t>
-            </a:r>
-          </a:p>
-          <a:p>
-            <a:r>
-              <a:rPr lang="de-AT" sz="2800" b="1" dirty="0"/>
-              <a:t>Kamera:</a:t>
-            </a:r>
-            <a:r>
-              <a:rPr lang="de-AT" sz="2800" dirty="0"/>
-              <a:t> Pi </a:t>
-            </a:r>
-            <a:r>
-              <a:rPr lang="de-AT" sz="2800" dirty="0" err="1"/>
-              <a:t>Camera</a:t>
-            </a:r>
-            <a:r>
-              <a:rPr lang="de-AT" sz="2800" dirty="0"/>
-              <a:t> 3 Wide </a:t>
-            </a:r>
-            <a:r>
-              <a:rPr lang="de-AT" sz="2800" dirty="0" err="1"/>
-              <a:t>NoIR</a:t>
-            </a:r>
-            <a:endParaRPr lang="de-AT" sz="2800" dirty="0"/>
-          </a:p>
-          <a:p>
-            <a:r>
-              <a:rPr lang="de-AT" sz="2800" b="1" dirty="0"/>
-              <a:t>Software:</a:t>
-            </a:r>
-            <a:r>
-              <a:rPr lang="de-AT" sz="2800" dirty="0"/>
-              <a:t> Python + </a:t>
-            </a:r>
-            <a:r>
-              <a:rPr lang="de-AT" sz="2800" dirty="0" err="1"/>
-              <a:t>OpenCV</a:t>
-            </a:r>
-            <a:r>
-              <a:rPr lang="de-AT" sz="2800" dirty="0"/>
-              <a:t> + </a:t>
-            </a:r>
-            <a:r>
-              <a:rPr lang="de-AT" sz="2800" dirty="0" err="1"/>
-              <a:t>MediaPipe</a:t>
-            </a:r>
-            <a:endParaRPr lang="de-AT" sz="2800" dirty="0"/>
-          </a:p>
-          <a:p>
-            <a:r>
-              <a:rPr lang="de-AT" sz="2800" b="1" dirty="0"/>
-              <a:t>Anzeige:</a:t>
-            </a:r>
-            <a:r>
-              <a:rPr lang="de-AT" sz="2800" dirty="0"/>
-              <a:t> Max7219 LED-Module</a:t>
-            </a:r>
+            <a:endParaRPr lang="en-GB" dirty="0"/>
           </a:p>
           <a:p>
             <a:endParaRPr lang="de-AT" dirty="0"/>
-          </a:p>
-          <a:p>
-            <a:r>
-              <a:rPr lang="de-AT" b="1" dirty="0"/>
-              <a:t>Herausforderungen</a:t>
-            </a:r>
-          </a:p>
-          <a:p>
-            <a:r>
-              <a:rPr lang="de-AT" sz="2800" dirty="0"/>
-              <a:t>Echtzeitverarbeitung auf Raspberry Pi</a:t>
-            </a:r>
-          </a:p>
-          <a:p>
-            <a:r>
-              <a:rPr lang="de-AT" sz="2800" dirty="0"/>
-              <a:t>Präzise Personenerkennung</a:t>
-            </a:r>
-          </a:p>
-          <a:p>
-            <a:r>
-              <a:rPr lang="de-AT" sz="2800" dirty="0"/>
-              <a:t>Stabile LED-Ansteuerung</a:t>
-            </a:r>
-            <a:endParaRPr lang="de-DE" dirty="0"/>
           </a:p>
         </p:txBody>
       </p:sp>
     </p:spTree>
     <p:extLst>
       <p:ext uri="{BB962C8B-B14F-4D97-AF65-F5344CB8AC3E}">
-        <p14:creationId xmlns:p14="http://schemas.microsoft.com/office/powerpoint/2010/main" val="2583020303"/>
+        <p14:creationId xmlns:p14="http://schemas.microsoft.com/office/powerpoint/2010/main" val="2662080396"/>
+      </p:ext>
+    </p:extLst>
+  </p:cSld>
+  <p:clrMapOvr>
+    <a:masterClrMapping/>
+  </p:clrMapOvr>
+</p:sld>
+</file>
+
+<file path=ppt/slides/slide21.xml><?xml version="1.0" encoding="utf-8"?>
+<p:sld xmlns:a="http://schemas.openxmlformats.org/drawingml/2006/main" xmlns:r="http://schemas.openxmlformats.org/officeDocument/2006/relationships" xmlns:p="http://schemas.openxmlformats.org/presentationml/2006/main">
+  <p:cSld>
+    <p:spTree>
+      <p:nvGrpSpPr>
+        <p:cNvPr id="1" name=""/>
+        <p:cNvGrpSpPr/>
+        <p:nvPr/>
+      </p:nvGrpSpPr>
+      <p:grpSpPr>
+        <a:xfrm>
+          <a:off x="0" y="0"/>
+          <a:ext cx="0" cy="0"/>
+          <a:chOff x="0" y="0"/>
+          <a:chExt cx="0" cy="0"/>
+        </a:xfrm>
+      </p:grpSpPr>
+      <p:sp>
+        <p:nvSpPr>
+          <p:cNvPr id="3" name="Titel 2">
+            <a:extLst>
+              <a:ext uri="{FF2B5EF4-FFF2-40B4-BE49-F238E27FC236}">
+                <a16:creationId xmlns:a16="http://schemas.microsoft.com/office/drawing/2014/main" id="{36D623AB-AB96-1710-0A7B-AEBB022F2306}"/>
+              </a:ext>
+            </a:extLst>
+          </p:cNvPr>
+          <p:cNvSpPr>
+            <a:spLocks noGrp="1"/>
+          </p:cNvSpPr>
+          <p:nvPr>
+            <p:ph type="title"/>
+          </p:nvPr>
+        </p:nvSpPr>
+        <p:spPr/>
+        <p:txBody>
+          <a:bodyPr/>
+          <a:lstStyle/>
+          <a:p>
+            <a:pPr rtl="0"/>
+            <a:r>
+              <a:rPr lang="de-AT" dirty="0"/>
+              <a:t>Zusammenfassung</a:t>
+            </a:r>
+          </a:p>
+        </p:txBody>
+      </p:sp>
+      <p:sp>
+        <p:nvSpPr>
+          <p:cNvPr id="4" name="Textplatzhalter 3">
+            <a:extLst>
+              <a:ext uri="{FF2B5EF4-FFF2-40B4-BE49-F238E27FC236}">
+                <a16:creationId xmlns:a16="http://schemas.microsoft.com/office/drawing/2014/main" id="{27794161-D942-764E-0805-D9F4894C1A28}"/>
+              </a:ext>
+            </a:extLst>
+          </p:cNvPr>
+          <p:cNvSpPr>
+            <a:spLocks noGrp="1"/>
+          </p:cNvSpPr>
+          <p:nvPr>
+            <p:ph type="body" sz="quarter" idx="10"/>
+          </p:nvPr>
+        </p:nvSpPr>
+        <p:spPr/>
+        <p:txBody>
+          <a:bodyPr/>
+          <a:lstStyle/>
+          <a:p>
+            <a:r>
+              <a:rPr lang="de-AT" dirty="0"/>
+              <a:t>….wichtigste 3-4 Punkte</a:t>
+            </a:r>
+          </a:p>
+        </p:txBody>
+      </p:sp>
+    </p:spTree>
+    <p:extLst>
+      <p:ext uri="{BB962C8B-B14F-4D97-AF65-F5344CB8AC3E}">
+        <p14:creationId xmlns:p14="http://schemas.microsoft.com/office/powerpoint/2010/main" val="3176726208"/>
       </p:ext>
     </p:extLst>
   </p:cSld>
@@ -29643,7 +32242,7 @@
           <p:cNvPr id="2" name="Titel 1">
             <a:extLst>
               <a:ext uri="{FF2B5EF4-FFF2-40B4-BE49-F238E27FC236}">
-                <a16:creationId xmlns:a16="http://schemas.microsoft.com/office/drawing/2014/main" id="{6607AEB2-7E27-CDF7-F979-975329B5EEC1}"/>
+                <a16:creationId xmlns:a16="http://schemas.microsoft.com/office/drawing/2014/main" id="{900478CB-DC17-979A-9EB1-12BF53A3126E}"/>
               </a:ext>
             </a:extLst>
           </p:cNvPr>
@@ -29659,16 +32258,20 @@
           <a:bodyPr/>
           <a:lstStyle/>
           <a:p>
-            <a:endParaRPr lang="de-DE" dirty="0"/>
+            <a:r>
+              <a:rPr lang="en-GB" dirty="0" err="1"/>
+              <a:t>Einführung</a:t>
+            </a:r>
+            <a:endParaRPr lang="de-AT" dirty="0"/>
           </a:p>
         </p:txBody>
       </p:sp>
       <p:sp>
         <p:nvSpPr>
-          <p:cNvPr id="3" name="Bildplatzhalter 2">
+          <p:cNvPr id="3" name="Textplatzhalter 2">
             <a:extLst>
               <a:ext uri="{FF2B5EF4-FFF2-40B4-BE49-F238E27FC236}">
-                <a16:creationId xmlns:a16="http://schemas.microsoft.com/office/drawing/2014/main" id="{CA536F86-3AE5-5FDD-A8B5-6B0C8002E9D6}"/>
+                <a16:creationId xmlns:a16="http://schemas.microsoft.com/office/drawing/2014/main" id="{31820583-06D2-6D1F-BAAF-A8596E852D45}"/>
               </a:ext>
             </a:extLst>
           </p:cNvPr>
@@ -29676,7 +32279,7 @@
             <a:spLocks noGrp="1"/>
           </p:cNvSpPr>
           <p:nvPr>
-            <p:ph type="pic" sz="quarter" idx="10"/>
+            <p:ph type="body" idx="1"/>
           </p:nvPr>
         </p:nvSpPr>
         <p:spPr/>
@@ -29684,14 +32287,98 @@
           <a:bodyPr/>
           <a:lstStyle/>
           <a:p>
-            <a:endParaRPr lang="de-DE"/>
+            <a:pPr marL="457200" indent="-457200">
+              <a:buFont typeface="Arial" panose="020B0604020202020204" pitchFamily="34" charset="0"/>
+              <a:buChar char="•"/>
+            </a:pPr>
+            <a:r>
+              <a:rPr lang="en-GB" dirty="0"/>
+              <a:t>Raspberry Pi 5</a:t>
+            </a:r>
+          </a:p>
+          <a:p>
+            <a:pPr marL="457200" indent="-457200">
+              <a:buFont typeface="Arial" panose="020B0604020202020204" pitchFamily="34" charset="0"/>
+              <a:buChar char="•"/>
+            </a:pPr>
+            <a:endParaRPr lang="de-AT" dirty="0"/>
+          </a:p>
+          <a:p>
+            <a:pPr marL="457200" indent="-457200">
+              <a:buFont typeface="Arial" panose="020B0604020202020204" pitchFamily="34" charset="0"/>
+              <a:buChar char="•"/>
+            </a:pPr>
+            <a:r>
+              <a:rPr lang="de-AT" dirty="0"/>
+              <a:t>Pi </a:t>
+            </a:r>
+            <a:r>
+              <a:rPr lang="de-AT" dirty="0" err="1"/>
+              <a:t>Camera</a:t>
+            </a:r>
+            <a:r>
+              <a:rPr lang="de-AT" dirty="0"/>
+              <a:t> 3</a:t>
+            </a:r>
+          </a:p>
+          <a:p>
+            <a:pPr marL="457200" indent="-457200">
+              <a:buFont typeface="Arial" panose="020B0604020202020204" pitchFamily="34" charset="0"/>
+              <a:buChar char="•"/>
+            </a:pPr>
+            <a:endParaRPr lang="de-AT" dirty="0"/>
+          </a:p>
+          <a:p>
+            <a:pPr marL="457200" indent="-457200">
+              <a:buFont typeface="Arial" panose="020B0604020202020204" pitchFamily="34" charset="0"/>
+              <a:buChar char="•"/>
+            </a:pPr>
+            <a:r>
+              <a:rPr lang="de-AT" dirty="0"/>
+              <a:t>MAX7219</a:t>
+            </a:r>
+          </a:p>
+          <a:p>
+            <a:pPr marL="457200" indent="-457200">
+              <a:buFont typeface="Arial" panose="020B0604020202020204" pitchFamily="34" charset="0"/>
+              <a:buChar char="•"/>
+            </a:pPr>
+            <a:endParaRPr lang="de-AT" dirty="0"/>
+          </a:p>
+          <a:p>
+            <a:pPr marL="457200" indent="-457200">
+              <a:buFont typeface="Arial" panose="020B0604020202020204" pitchFamily="34" charset="0"/>
+              <a:buChar char="•"/>
+            </a:pPr>
+            <a:r>
+              <a:rPr lang="de-AT" dirty="0"/>
+              <a:t>Verbindungsplatinen</a:t>
+            </a:r>
+          </a:p>
+          <a:p>
+            <a:pPr marL="457200" indent="-457200">
+              <a:buFont typeface="Arial" panose="020B0604020202020204" pitchFamily="34" charset="0"/>
+              <a:buChar char="•"/>
+            </a:pPr>
+            <a:endParaRPr lang="de-AT" dirty="0"/>
+          </a:p>
+          <a:p>
+            <a:pPr marL="457200" indent="-457200">
+              <a:buFont typeface="Arial" panose="020B0604020202020204" pitchFamily="34" charset="0"/>
+              <a:buChar char="•"/>
+            </a:pPr>
+            <a:r>
+              <a:rPr lang="de-AT" dirty="0"/>
+              <a:t>Case</a:t>
+            </a:r>
+            <a:endParaRPr lang="en-GB" dirty="0"/>
           </a:p>
         </p:txBody>
       </p:sp>
     </p:spTree>
     <p:extLst>
       <p:ext uri="{BB962C8B-B14F-4D97-AF65-F5344CB8AC3E}">
-        <p14:creationId xmlns:p14="http://schemas.microsoft.com/office/powerpoint/2010/main" val="120320556"/>
+        <p14:creationId xmlns:p14="http://schemas.microsoft.com/office/powerpoint/2010/main" val="1407555994"/>
       </p:ext>
     </p:extLst>
   </p:cSld>
@@ -29761,39 +32448,28 @@
             </a:pPr>
             <a:r>
               <a:rPr lang="de-DE" sz="3200" dirty="0"/>
+              <a:t>Kamera Ansteuerung</a:t>
+            </a:r>
+          </a:p>
+          <a:p>
+            <a:pPr marL="457200" indent="-457200">
+              <a:buFont typeface="Arial" panose="020B0604020202020204" pitchFamily="34" charset="0"/>
+              <a:buChar char="•"/>
+            </a:pPr>
+            <a:r>
+              <a:rPr lang="de-DE" sz="3200" dirty="0"/>
               <a:t>Led-Matrix</a:t>
             </a:r>
           </a:p>
-        </p:txBody>
-      </p:sp>
-      <p:sp>
-        <p:nvSpPr>
-          <p:cNvPr id="3" name="Textplatzhalter 2">
-            <a:extLst>
-              <a:ext uri="{FF2B5EF4-FFF2-40B4-BE49-F238E27FC236}">
-                <a16:creationId xmlns:a16="http://schemas.microsoft.com/office/drawing/2014/main" id="{50D921CF-88A6-B6F5-7EF3-F9965736CDB4}"/>
-              </a:ext>
-            </a:extLst>
-          </p:cNvPr>
-          <p:cNvSpPr>
-            <a:spLocks noGrp="1"/>
-          </p:cNvSpPr>
-          <p:nvPr>
-            <p:ph type="body" idx="10"/>
-          </p:nvPr>
-        </p:nvSpPr>
-        <p:spPr/>
-        <p:txBody>
-          <a:bodyPr/>
-          <a:lstStyle/>
           <a:p>
+            <a:pPr marL="457200" indent="-457200">
+              <a:buFont typeface="Arial" panose="020B0604020202020204" pitchFamily="34" charset="0"/>
+              <a:buChar char="•"/>
+            </a:pPr>
             <a:r>
-              <a:rPr lang="de-DE" dirty="0"/>
-              <a:t>Manuel</a:t>
+              <a:rPr lang="de-DE" sz="3200" dirty="0"/>
+              <a:t>Simulation der Verbindungsplatinen</a:t>
             </a:r>
-          </a:p>
-          <a:p>
-            <a:endParaRPr lang="de-DE" dirty="0"/>
           </a:p>
         </p:txBody>
       </p:sp>
@@ -29820,8 +32496,33 @@
           <a:p>
             <a:r>
               <a:rPr lang="de-DE" dirty="0"/>
-              <a:t>Arbeitsaufteilung</a:t>
+              <a:t>Robert</a:t>
             </a:r>
+          </a:p>
+        </p:txBody>
+      </p:sp>
+      <p:sp>
+        <p:nvSpPr>
+          <p:cNvPr id="6" name="Textplatzhalter 5">
+            <a:extLst>
+              <a:ext uri="{FF2B5EF4-FFF2-40B4-BE49-F238E27FC236}">
+                <a16:creationId xmlns:a16="http://schemas.microsoft.com/office/drawing/2014/main" id="{15489D09-CEE7-0C2B-D5F6-A7B450EB1DAE}"/>
+              </a:ext>
+            </a:extLst>
+          </p:cNvPr>
+          <p:cNvSpPr>
+            <a:spLocks noGrp="1"/>
+          </p:cNvSpPr>
+          <p:nvPr>
+            <p:ph type="body" idx="10"/>
+          </p:nvPr>
+        </p:nvSpPr>
+        <p:spPr/>
+        <p:txBody>
+          <a:bodyPr/>
+          <a:lstStyle/>
+          <a:p>
+            <a:endParaRPr lang="de-AT"/>
           </a:p>
         </p:txBody>
       </p:sp>
@@ -29855,12 +32556,172 @@
           <a:chExt cx="0" cy="0"/>
         </a:xfrm>
       </p:grpSpPr>
+      <p:pic>
+        <p:nvPicPr>
+          <p:cNvPr id="6" name="Inhaltsplatzhalter 5">
+            <a:extLst>
+              <a:ext uri="{FF2B5EF4-FFF2-40B4-BE49-F238E27FC236}">
+                <a16:creationId xmlns:a16="http://schemas.microsoft.com/office/drawing/2014/main" id="{69288866-0B66-E12A-1A26-4F4297EAD387}"/>
+              </a:ext>
+            </a:extLst>
+          </p:cNvPr>
+          <p:cNvPicPr>
+            <a:picLocks noGrp="1" noChangeAspect="1"/>
+          </p:cNvPicPr>
+          <p:nvPr>
+            <p:ph sz="half" idx="3"/>
+          </p:nvPr>
+        </p:nvPicPr>
+        <p:blipFill>
+          <a:blip r:embed="rId2"/>
+          <a:stretch>
+            <a:fillRect/>
+          </a:stretch>
+        </p:blipFill>
+        <p:spPr>
+          <a:xfrm>
+            <a:off x="12386141" y="2460625"/>
+            <a:ext cx="4724677" cy="7559484"/>
+          </a:xfrm>
+          <a:prstGeom prst="rect">
+            <a:avLst/>
+          </a:prstGeom>
+          <a:noFill/>
+        </p:spPr>
+      </p:pic>
       <p:sp>
         <p:nvSpPr>
-          <p:cNvPr id="2" name="Titel 1">
+          <p:cNvPr id="3" name="Textplatzhalter 2">
             <a:extLst>
               <a:ext uri="{FF2B5EF4-FFF2-40B4-BE49-F238E27FC236}">
-                <a16:creationId xmlns:a16="http://schemas.microsoft.com/office/drawing/2014/main" id="{1E78E237-D6B9-628C-4B91-80C95E7C671D}"/>
+                <a16:creationId xmlns:a16="http://schemas.microsoft.com/office/drawing/2014/main" id="{8BFAEB38-8807-CC03-2222-A9D3901F9716}"/>
+              </a:ext>
+            </a:extLst>
+          </p:cNvPr>
+          <p:cNvSpPr>
+            <a:spLocks noGrp="1"/>
+          </p:cNvSpPr>
+          <p:nvPr>
+            <p:ph type="body" idx="1"/>
+          </p:nvPr>
+        </p:nvSpPr>
+        <p:spPr>
+          <a:xfrm>
+            <a:off x="979488" y="2460923"/>
+            <a:ext cx="8771002" cy="7560840"/>
+          </a:xfrm>
+        </p:spPr>
+        <p:txBody>
+          <a:bodyPr>
+            <a:normAutofit/>
+          </a:bodyPr>
+          <a:lstStyle/>
+          <a:p>
+            <a:pPr>
+              <a:spcAft>
+                <a:spcPts val="600"/>
+              </a:spcAft>
+            </a:pPr>
+            <a:r>
+              <a:rPr lang="en-US" dirty="0"/>
+              <a:t>Initialization</a:t>
+            </a:r>
+          </a:p>
+          <a:p>
+            <a:pPr marL="457200" indent="-457200">
+              <a:spcAft>
+                <a:spcPts val="600"/>
+              </a:spcAft>
+              <a:buFont typeface="Arial" panose="020B0604020202020204" pitchFamily="34" charset="0"/>
+              <a:buChar char="•"/>
+            </a:pPr>
+            <a:r>
+              <a:rPr lang="en-US" dirty="0"/>
+              <a:t>Kamera </a:t>
+            </a:r>
+            <a:r>
+              <a:rPr lang="en-US" dirty="0" err="1"/>
+              <a:t>starten</a:t>
+            </a:r>
+            <a:endParaRPr lang="en-US" dirty="0"/>
+          </a:p>
+          <a:p>
+            <a:pPr marL="457200" indent="-457200">
+              <a:spcAft>
+                <a:spcPts val="600"/>
+              </a:spcAft>
+              <a:buFont typeface="Arial" panose="020B0604020202020204" pitchFamily="34" charset="0"/>
+              <a:buChar char="•"/>
+            </a:pPr>
+            <a:endParaRPr lang="en-US" dirty="0"/>
+          </a:p>
+          <a:p>
+            <a:pPr marL="457200" indent="-457200">
+              <a:spcAft>
+                <a:spcPts val="600"/>
+              </a:spcAft>
+              <a:buFont typeface="Arial" panose="020B0604020202020204" pitchFamily="34" charset="0"/>
+              <a:buChar char="•"/>
+            </a:pPr>
+            <a:r>
+              <a:rPr lang="en-US" dirty="0"/>
+              <a:t>KI-Modelle</a:t>
+            </a:r>
+          </a:p>
+          <a:p>
+            <a:pPr marL="457200" indent="-457200">
+              <a:spcAft>
+                <a:spcPts val="600"/>
+              </a:spcAft>
+              <a:buFont typeface="Arial" panose="020B0604020202020204" pitchFamily="34" charset="0"/>
+              <a:buChar char="•"/>
+            </a:pPr>
+            <a:endParaRPr lang="en-US" dirty="0"/>
+          </a:p>
+          <a:p>
+            <a:pPr marL="457200" indent="-457200">
+              <a:spcAft>
+                <a:spcPts val="600"/>
+              </a:spcAft>
+              <a:buFont typeface="Arial" panose="020B0604020202020204" pitchFamily="34" charset="0"/>
+              <a:buChar char="•"/>
+            </a:pPr>
+            <a:r>
+              <a:rPr lang="en-US" dirty="0"/>
+              <a:t>KNN </a:t>
+            </a:r>
+            <a:r>
+              <a:rPr lang="en-US" dirty="0" err="1"/>
+              <a:t>starten</a:t>
+            </a:r>
+            <a:endParaRPr lang="en-US" dirty="0"/>
+          </a:p>
+          <a:p>
+            <a:pPr marL="457200" indent="-457200">
+              <a:spcAft>
+                <a:spcPts val="600"/>
+              </a:spcAft>
+              <a:buFont typeface="Arial" panose="020B0604020202020204" pitchFamily="34" charset="0"/>
+              <a:buChar char="•"/>
+            </a:pPr>
+            <a:endParaRPr lang="en-US" dirty="0"/>
+          </a:p>
+          <a:p>
+            <a:pPr>
+              <a:spcAft>
+                <a:spcPts val="600"/>
+              </a:spcAft>
+            </a:pPr>
+            <a:endParaRPr lang="de-AT" dirty="0"/>
+          </a:p>
+        </p:txBody>
+      </p:sp>
+      <p:sp>
+        <p:nvSpPr>
+          <p:cNvPr id="4" name="Titel 3">
+            <a:extLst>
+              <a:ext uri="{FF2B5EF4-FFF2-40B4-BE49-F238E27FC236}">
+                <a16:creationId xmlns:a16="http://schemas.microsoft.com/office/drawing/2014/main" id="{B6332A4B-BFA5-4137-77FE-76CE323A5B1C}"/>
               </a:ext>
             </a:extLst>
           </p:cNvPr>
@@ -29871,54 +32732,26 @@
             <p:ph type="title"/>
           </p:nvPr>
         </p:nvSpPr>
-        <p:spPr/>
+        <p:spPr>
+          <a:xfrm>
+            <a:off x="979488" y="588715"/>
+            <a:ext cx="12312922" cy="780637"/>
+          </a:xfrm>
+        </p:spPr>
         <p:txBody>
-          <a:bodyPr/>
+          <a:bodyPr>
+            <a:normAutofit/>
+          </a:bodyPr>
           <a:lstStyle/>
           <a:p>
             <a:r>
               <a:rPr lang="en-GB" dirty="0" err="1"/>
-              <a:t>Personenerfassung</a:t>
+              <a:t>Programm</a:t>
             </a:r>
-            <a:endParaRPr lang="de-AT" dirty="0"/>
-          </a:p>
-        </p:txBody>
-      </p:sp>
-      <p:sp>
-        <p:nvSpPr>
-          <p:cNvPr id="3" name="Textplatzhalter 2">
-            <a:extLst>
-              <a:ext uri="{FF2B5EF4-FFF2-40B4-BE49-F238E27FC236}">
-                <a16:creationId xmlns:a16="http://schemas.microsoft.com/office/drawing/2014/main" id="{1D660DAB-9E5B-AE58-5357-36F15EC751F0}"/>
-              </a:ext>
-            </a:extLst>
-          </p:cNvPr>
-          <p:cNvSpPr>
-            <a:spLocks noGrp="1"/>
-          </p:cNvSpPr>
-          <p:nvPr>
-            <p:ph type="body" idx="1"/>
-          </p:nvPr>
-        </p:nvSpPr>
-        <p:spPr/>
-        <p:txBody>
-          <a:bodyPr/>
-          <a:lstStyle/>
-          <a:p>
             <a:r>
               <a:rPr lang="en-GB" dirty="0"/>
-              <a:t>Bis </a:t>
+              <a:t> Start</a:t>
             </a:r>
-            <a:r>
-              <a:rPr lang="en-GB" dirty="0" err="1"/>
-              <a:t>jetzt</a:t>
-            </a:r>
-            <a:r>
-              <a:rPr lang="en-GB"/>
-              <a:t>:</a:t>
-            </a:r>
-          </a:p>
-          <a:p>
             <a:endParaRPr lang="de-AT" dirty="0"/>
           </a:p>
         </p:txBody>
@@ -29926,7 +32759,7 @@
     </p:spTree>
     <p:extLst>
       <p:ext uri="{BB962C8B-B14F-4D97-AF65-F5344CB8AC3E}">
-        <p14:creationId xmlns:p14="http://schemas.microsoft.com/office/powerpoint/2010/main" val="2573936215"/>
+        <p14:creationId xmlns:p14="http://schemas.microsoft.com/office/powerpoint/2010/main" val="700325312"/>
       </p:ext>
     </p:extLst>
   </p:cSld>
@@ -29953,12 +32786,151 @@
           <a:chExt cx="0" cy="0"/>
         </a:xfrm>
       </p:grpSpPr>
+      <p:pic>
+        <p:nvPicPr>
+          <p:cNvPr id="12" name="Inhaltsplatzhalter 11">
+            <a:extLst>
+              <a:ext uri="{FF2B5EF4-FFF2-40B4-BE49-F238E27FC236}">
+                <a16:creationId xmlns:a16="http://schemas.microsoft.com/office/drawing/2014/main" id="{4D1A9F7E-1611-7FCB-52F1-161430911317}"/>
+              </a:ext>
+            </a:extLst>
+          </p:cNvPr>
+          <p:cNvPicPr>
+            <a:picLocks noGrp="1" noChangeAspect="1"/>
+          </p:cNvPicPr>
+          <p:nvPr>
+            <p:ph sz="half" idx="3"/>
+          </p:nvPr>
+        </p:nvPicPr>
+        <p:blipFill>
+          <a:blip r:embed="rId2"/>
+          <a:stretch>
+            <a:fillRect/>
+          </a:stretch>
+        </p:blipFill>
+        <p:spPr>
+          <a:xfrm>
+            <a:off x="12272748" y="2460625"/>
+            <a:ext cx="4951462" cy="7559484"/>
+          </a:xfrm>
+          <a:prstGeom prst="rect">
+            <a:avLst/>
+          </a:prstGeom>
+          <a:noFill/>
+        </p:spPr>
+      </p:pic>
       <p:sp>
         <p:nvSpPr>
-          <p:cNvPr id="2" name="Titel 1">
+          <p:cNvPr id="3" name="Textplatzhalter 2">
             <a:extLst>
               <a:ext uri="{FF2B5EF4-FFF2-40B4-BE49-F238E27FC236}">
-                <a16:creationId xmlns:a16="http://schemas.microsoft.com/office/drawing/2014/main" id="{5822F618-A2F8-F55A-FD4A-CB6AE42107F4}"/>
+                <a16:creationId xmlns:a16="http://schemas.microsoft.com/office/drawing/2014/main" id="{027058CD-77B2-7B64-9707-62CD91BA24BC}"/>
+              </a:ext>
+            </a:extLst>
+          </p:cNvPr>
+          <p:cNvSpPr>
+            <a:spLocks noGrp="1"/>
+          </p:cNvSpPr>
+          <p:nvPr>
+            <p:ph type="body" idx="1"/>
+          </p:nvPr>
+        </p:nvSpPr>
+        <p:spPr>
+          <a:xfrm>
+            <a:off x="979488" y="2460923"/>
+            <a:ext cx="8771002" cy="7560840"/>
+          </a:xfrm>
+        </p:spPr>
+        <p:txBody>
+          <a:bodyPr>
+            <a:normAutofit/>
+          </a:bodyPr>
+          <a:lstStyle/>
+          <a:p>
+            <a:pPr marL="457200" indent="-457200">
+              <a:spcAft>
+                <a:spcPts val="600"/>
+              </a:spcAft>
+              <a:buFont typeface="Arial" panose="020B0604020202020204" pitchFamily="34" charset="0"/>
+              <a:buChar char="•"/>
+            </a:pPr>
+            <a:r>
+              <a:rPr lang="en-GB" dirty="0"/>
+              <a:t>100 Frames ( Keine Person )</a:t>
+            </a:r>
+          </a:p>
+          <a:p>
+            <a:pPr marL="457200" indent="-457200">
+              <a:spcAft>
+                <a:spcPts val="600"/>
+              </a:spcAft>
+              <a:buFont typeface="Arial" panose="020B0604020202020204" pitchFamily="34" charset="0"/>
+              <a:buChar char="•"/>
+            </a:pPr>
+            <a:endParaRPr lang="en-GB" dirty="0"/>
+          </a:p>
+          <a:p>
+            <a:pPr marL="457200" indent="-457200">
+              <a:spcAft>
+                <a:spcPts val="600"/>
+              </a:spcAft>
+              <a:buFont typeface="Arial" panose="020B0604020202020204" pitchFamily="34" charset="0"/>
+              <a:buChar char="•"/>
+            </a:pPr>
+            <a:r>
+              <a:rPr lang="en-GB" dirty="0"/>
+              <a:t>BGR -&gt; </a:t>
+            </a:r>
+            <a:r>
+              <a:rPr lang="en-GB" dirty="0" err="1"/>
+              <a:t>Graustufenbild</a:t>
+            </a:r>
+            <a:endParaRPr lang="en-GB" dirty="0"/>
+          </a:p>
+          <a:p>
+            <a:pPr marL="457200" indent="-457200">
+              <a:spcAft>
+                <a:spcPts val="600"/>
+              </a:spcAft>
+              <a:buFont typeface="Arial" panose="020B0604020202020204" pitchFamily="34" charset="0"/>
+              <a:buChar char="•"/>
+            </a:pPr>
+            <a:endParaRPr lang="en-GB" dirty="0"/>
+          </a:p>
+          <a:p>
+            <a:pPr marL="457200" indent="-457200">
+              <a:spcAft>
+                <a:spcPts val="600"/>
+              </a:spcAft>
+              <a:buFont typeface="Arial" panose="020B0604020202020204" pitchFamily="34" charset="0"/>
+              <a:buChar char="•"/>
+            </a:pPr>
+            <a:r>
+              <a:rPr lang="en-GB" dirty="0"/>
+              <a:t>KNN </a:t>
+            </a:r>
+            <a:r>
+              <a:rPr lang="en-GB" dirty="0" err="1"/>
+              <a:t>lernt</a:t>
+            </a:r>
+            <a:r>
+              <a:rPr lang="en-GB" dirty="0"/>
+              <a:t> </a:t>
+            </a:r>
+            <a:r>
+              <a:rPr lang="en-GB" dirty="0" err="1"/>
+              <a:t>Hintergrund</a:t>
+            </a:r>
+            <a:endParaRPr lang="de-AT" dirty="0"/>
+          </a:p>
+        </p:txBody>
+      </p:sp>
+      <p:sp>
+        <p:nvSpPr>
+          <p:cNvPr id="4" name="Titel 3">
+            <a:extLst>
+              <a:ext uri="{FF2B5EF4-FFF2-40B4-BE49-F238E27FC236}">
+                <a16:creationId xmlns:a16="http://schemas.microsoft.com/office/drawing/2014/main" id="{BC92C6FE-F8C0-4B41-0D56-699714DE7865}"/>
               </a:ext>
             </a:extLst>
           </p:cNvPr>
@@ -29969,46 +32941,21 @@
             <p:ph type="title"/>
           </p:nvPr>
         </p:nvSpPr>
-        <p:spPr/>
+        <p:spPr>
+          <a:xfrm>
+            <a:off x="979488" y="588715"/>
+            <a:ext cx="12312922" cy="780637"/>
+          </a:xfrm>
+        </p:spPr>
         <p:txBody>
-          <a:bodyPr/>
+          <a:bodyPr>
+            <a:normAutofit/>
+          </a:bodyPr>
           <a:lstStyle/>
           <a:p>
             <a:r>
               <a:rPr lang="en-GB" dirty="0" err="1"/>
-              <a:t>Personenerfassung</a:t>
-            </a:r>
-            <a:br>
-              <a:rPr lang="en-GB" dirty="0"/>
-            </a:br>
-            <a:endParaRPr lang="de-AT" dirty="0"/>
-          </a:p>
-        </p:txBody>
-      </p:sp>
-      <p:sp>
-        <p:nvSpPr>
-          <p:cNvPr id="3" name="Textplatzhalter 2">
-            <a:extLst>
-              <a:ext uri="{FF2B5EF4-FFF2-40B4-BE49-F238E27FC236}">
-                <a16:creationId xmlns:a16="http://schemas.microsoft.com/office/drawing/2014/main" id="{DDEF813E-0A59-3161-4BFB-AB5AE7EC1005}"/>
-              </a:ext>
-            </a:extLst>
-          </p:cNvPr>
-          <p:cNvSpPr>
-            <a:spLocks noGrp="1"/>
-          </p:cNvSpPr>
-          <p:nvPr>
-            <p:ph type="body" idx="1"/>
-          </p:nvPr>
-        </p:nvSpPr>
-        <p:spPr/>
-        <p:txBody>
-          <a:bodyPr/>
-          <a:lstStyle/>
-          <a:p>
-            <a:r>
-              <a:rPr lang="en-GB" dirty="0" err="1"/>
-              <a:t>Probleme</a:t>
+              <a:t>Kalibrierung</a:t>
             </a:r>
             <a:endParaRPr lang="de-AT" dirty="0"/>
           </a:p>
@@ -30017,7 +32964,7 @@
     </p:spTree>
     <p:extLst>
       <p:ext uri="{BB962C8B-B14F-4D97-AF65-F5344CB8AC3E}">
-        <p14:creationId xmlns:p14="http://schemas.microsoft.com/office/powerpoint/2010/main" val="337789853"/>
+        <p14:creationId xmlns:p14="http://schemas.microsoft.com/office/powerpoint/2010/main" val="202108956"/>
       </p:ext>
     </p:extLst>
   </p:cSld>
@@ -30044,12 +32991,172 @@
           <a:chExt cx="0" cy="0"/>
         </a:xfrm>
       </p:grpSpPr>
+      <p:pic>
+        <p:nvPicPr>
+          <p:cNvPr id="6" name="Inhaltsplatzhalter 5">
+            <a:extLst>
+              <a:ext uri="{FF2B5EF4-FFF2-40B4-BE49-F238E27FC236}">
+                <a16:creationId xmlns:a16="http://schemas.microsoft.com/office/drawing/2014/main" id="{99E8EE6B-C21C-17C4-967A-414CC2967725}"/>
+              </a:ext>
+            </a:extLst>
+          </p:cNvPr>
+          <p:cNvPicPr>
+            <a:picLocks noGrp="1" noChangeAspect="1"/>
+          </p:cNvPicPr>
+          <p:nvPr>
+            <p:ph sz="half" idx="3"/>
+          </p:nvPr>
+        </p:nvPicPr>
+        <p:blipFill>
+          <a:blip r:embed="rId2"/>
+          <a:stretch>
+            <a:fillRect/>
+          </a:stretch>
+        </p:blipFill>
+        <p:spPr>
+          <a:xfrm>
+            <a:off x="11015984" y="2460625"/>
+            <a:ext cx="7464991" cy="7559484"/>
+          </a:xfrm>
+          <a:prstGeom prst="rect">
+            <a:avLst/>
+          </a:prstGeom>
+          <a:noFill/>
+        </p:spPr>
+      </p:pic>
       <p:sp>
         <p:nvSpPr>
-          <p:cNvPr id="2" name="Titel 1">
+          <p:cNvPr id="3" name="Textplatzhalter 2">
             <a:extLst>
               <a:ext uri="{FF2B5EF4-FFF2-40B4-BE49-F238E27FC236}">
-                <a16:creationId xmlns:a16="http://schemas.microsoft.com/office/drawing/2014/main" id="{11B75970-25C5-DE39-0F52-0BBDD30DCF0B}"/>
+                <a16:creationId xmlns:a16="http://schemas.microsoft.com/office/drawing/2014/main" id="{0DC0D51E-25B8-687F-F977-6525DB63D017}"/>
+              </a:ext>
+            </a:extLst>
+          </p:cNvPr>
+          <p:cNvSpPr>
+            <a:spLocks noGrp="1"/>
+          </p:cNvSpPr>
+          <p:nvPr>
+            <p:ph type="body" idx="1"/>
+          </p:nvPr>
+        </p:nvSpPr>
+        <p:spPr>
+          <a:xfrm>
+            <a:off x="979488" y="2460923"/>
+            <a:ext cx="8771002" cy="7560840"/>
+          </a:xfrm>
+        </p:spPr>
+        <p:txBody>
+          <a:bodyPr>
+            <a:normAutofit/>
+          </a:bodyPr>
+          <a:lstStyle/>
+          <a:p>
+            <a:pPr marL="457200" indent="-457200">
+              <a:spcAft>
+                <a:spcPts val="600"/>
+              </a:spcAft>
+              <a:buFont typeface="Arial" panose="020B0604020202020204" pitchFamily="34" charset="0"/>
+              <a:buChar char="•"/>
+            </a:pPr>
+            <a:r>
+              <a:rPr lang="en-GB" dirty="0"/>
+              <a:t>BGR -&gt; RGB</a:t>
+            </a:r>
+          </a:p>
+          <a:p>
+            <a:pPr marL="457200" indent="-457200">
+              <a:spcAft>
+                <a:spcPts val="600"/>
+              </a:spcAft>
+              <a:buFont typeface="Arial" panose="020B0604020202020204" pitchFamily="34" charset="0"/>
+              <a:buChar char="•"/>
+            </a:pPr>
+            <a:endParaRPr lang="de-AT" dirty="0"/>
+          </a:p>
+          <a:p>
+            <a:pPr marL="457200" indent="-457200">
+              <a:spcAft>
+                <a:spcPts val="600"/>
+              </a:spcAft>
+              <a:buFont typeface="Arial" panose="020B0604020202020204" pitchFamily="34" charset="0"/>
+              <a:buChar char="•"/>
+            </a:pPr>
+            <a:r>
+              <a:rPr lang="de-AT" dirty="0"/>
+              <a:t>Körper von Hintergrund trennen</a:t>
+            </a:r>
+          </a:p>
+          <a:p>
+            <a:pPr marL="457200" indent="-457200">
+              <a:spcAft>
+                <a:spcPts val="600"/>
+              </a:spcAft>
+              <a:buFont typeface="Arial" panose="020B0604020202020204" pitchFamily="34" charset="0"/>
+              <a:buChar char="•"/>
+            </a:pPr>
+            <a:endParaRPr lang="de-AT" dirty="0"/>
+          </a:p>
+          <a:p>
+            <a:pPr marL="457200" indent="-457200">
+              <a:spcAft>
+                <a:spcPts val="600"/>
+              </a:spcAft>
+              <a:buFont typeface="Arial" panose="020B0604020202020204" pitchFamily="34" charset="0"/>
+              <a:buChar char="•"/>
+            </a:pPr>
+            <a:r>
+              <a:rPr lang="de-AT" dirty="0"/>
+              <a:t>Hände Polygon</a:t>
+            </a:r>
+          </a:p>
+          <a:p>
+            <a:pPr marL="457200" indent="-457200">
+              <a:spcAft>
+                <a:spcPts val="600"/>
+              </a:spcAft>
+              <a:buFont typeface="Arial" panose="020B0604020202020204" pitchFamily="34" charset="0"/>
+              <a:buChar char="•"/>
+            </a:pPr>
+            <a:endParaRPr lang="de-AT" dirty="0"/>
+          </a:p>
+          <a:p>
+            <a:pPr marL="457200" indent="-457200">
+              <a:spcAft>
+                <a:spcPts val="600"/>
+              </a:spcAft>
+              <a:buFont typeface="Arial" panose="020B0604020202020204" pitchFamily="34" charset="0"/>
+              <a:buChar char="•"/>
+            </a:pPr>
+            <a:r>
+              <a:rPr lang="de-AT" dirty="0"/>
+              <a:t>Maske erstellen</a:t>
+            </a:r>
+          </a:p>
+          <a:p>
+            <a:pPr>
+              <a:spcAft>
+                <a:spcPts val="600"/>
+              </a:spcAft>
+            </a:pPr>
+            <a:endParaRPr lang="de-AT" dirty="0"/>
+          </a:p>
+          <a:p>
+            <a:pPr>
+              <a:spcAft>
+                <a:spcPts val="600"/>
+              </a:spcAft>
+            </a:pPr>
+            <a:endParaRPr lang="en-GB" dirty="0"/>
+          </a:p>
+        </p:txBody>
+      </p:sp>
+      <p:sp>
+        <p:nvSpPr>
+          <p:cNvPr id="4" name="Titel 3">
+            <a:extLst>
+              <a:ext uri="{FF2B5EF4-FFF2-40B4-BE49-F238E27FC236}">
+                <a16:creationId xmlns:a16="http://schemas.microsoft.com/office/drawing/2014/main" id="{C84ED622-F06E-5EBA-C42C-A9755BB4E69F}"/>
               </a:ext>
             </a:extLst>
           </p:cNvPr>
@@ -30060,43 +33167,21 @@
             <p:ph type="title"/>
           </p:nvPr>
         </p:nvSpPr>
-        <p:spPr/>
+        <p:spPr>
+          <a:xfrm>
+            <a:off x="979488" y="588715"/>
+            <a:ext cx="12312922" cy="780637"/>
+          </a:xfrm>
+        </p:spPr>
         <p:txBody>
-          <a:bodyPr/>
+          <a:bodyPr>
+            <a:normAutofit/>
+          </a:bodyPr>
           <a:lstStyle/>
           <a:p>
             <a:r>
               <a:rPr lang="en-GB" dirty="0"/>
-              <a:t>Led Module</a:t>
-            </a:r>
-            <a:endParaRPr lang="de-AT" dirty="0"/>
-          </a:p>
-        </p:txBody>
-      </p:sp>
-      <p:sp>
-        <p:nvSpPr>
-          <p:cNvPr id="3" name="Textplatzhalter 2">
-            <a:extLst>
-              <a:ext uri="{FF2B5EF4-FFF2-40B4-BE49-F238E27FC236}">
-                <a16:creationId xmlns:a16="http://schemas.microsoft.com/office/drawing/2014/main" id="{9E237261-779D-64EA-8777-F4153FA2CAEA}"/>
-              </a:ext>
-            </a:extLst>
-          </p:cNvPr>
-          <p:cNvSpPr>
-            <a:spLocks noGrp="1"/>
-          </p:cNvSpPr>
-          <p:nvPr>
-            <p:ph type="body" idx="1"/>
-          </p:nvPr>
-        </p:nvSpPr>
-        <p:spPr/>
-        <p:txBody>
-          <a:bodyPr/>
-          <a:lstStyle/>
-          <a:p>
-            <a:r>
-              <a:rPr lang="en-GB" dirty="0" err="1"/>
-              <a:t>Probleme</a:t>
+              <a:t>Main Loop</a:t>
             </a:r>
             <a:endParaRPr lang="de-AT" dirty="0"/>
           </a:p>
@@ -30105,7 +33190,7 @@
     </p:spTree>
     <p:extLst>
       <p:ext uri="{BB962C8B-B14F-4D97-AF65-F5344CB8AC3E}">
-        <p14:creationId xmlns:p14="http://schemas.microsoft.com/office/powerpoint/2010/main" val="2722135856"/>
+        <p14:creationId xmlns:p14="http://schemas.microsoft.com/office/powerpoint/2010/main" val="3998210863"/>
       </p:ext>
     </p:extLst>
   </p:cSld>
@@ -30132,12 +33217,179 @@
           <a:chExt cx="0" cy="0"/>
         </a:xfrm>
       </p:grpSpPr>
+      <p:pic>
+        <p:nvPicPr>
+          <p:cNvPr id="6" name="Inhaltsplatzhalter 5">
+            <a:extLst>
+              <a:ext uri="{FF2B5EF4-FFF2-40B4-BE49-F238E27FC236}">
+                <a16:creationId xmlns:a16="http://schemas.microsoft.com/office/drawing/2014/main" id="{6ADB392F-BD21-5188-B536-07A857FEF51B}"/>
+              </a:ext>
+            </a:extLst>
+          </p:cNvPr>
+          <p:cNvPicPr>
+            <a:picLocks noGrp="1" noChangeAspect="1"/>
+          </p:cNvPicPr>
+          <p:nvPr>
+            <p:ph sz="half" idx="3"/>
+          </p:nvPr>
+        </p:nvPicPr>
+        <p:blipFill>
+          <a:blip r:embed="rId2"/>
+          <a:stretch>
+            <a:fillRect/>
+          </a:stretch>
+        </p:blipFill>
+        <p:spPr>
+          <a:xfrm>
+            <a:off x="11167174" y="2460625"/>
+            <a:ext cx="7162610" cy="7559484"/>
+          </a:xfrm>
+          <a:prstGeom prst="rect">
+            <a:avLst/>
+          </a:prstGeom>
+          <a:noFill/>
+        </p:spPr>
+      </p:pic>
       <p:sp>
         <p:nvSpPr>
-          <p:cNvPr id="3" name="Titel 2">
+          <p:cNvPr id="3" name="Textplatzhalter 2">
             <a:extLst>
               <a:ext uri="{FF2B5EF4-FFF2-40B4-BE49-F238E27FC236}">
-                <a16:creationId xmlns:a16="http://schemas.microsoft.com/office/drawing/2014/main" id="{36D623AB-AB96-1710-0A7B-AEBB022F2306}"/>
+                <a16:creationId xmlns:a16="http://schemas.microsoft.com/office/drawing/2014/main" id="{1310B030-E566-F9AD-7CA4-03B395A41AF5}"/>
+              </a:ext>
+            </a:extLst>
+          </p:cNvPr>
+          <p:cNvSpPr>
+            <a:spLocks noGrp="1"/>
+          </p:cNvSpPr>
+          <p:nvPr>
+            <p:ph type="body" idx="1"/>
+          </p:nvPr>
+        </p:nvSpPr>
+        <p:spPr>
+          <a:xfrm>
+            <a:off x="979488" y="2460923"/>
+            <a:ext cx="8771002" cy="7560840"/>
+          </a:xfrm>
+        </p:spPr>
+        <p:txBody>
+          <a:bodyPr>
+            <a:normAutofit/>
+          </a:bodyPr>
+          <a:lstStyle/>
+          <a:p>
+            <a:pPr marL="457200" indent="-457200">
+              <a:spcAft>
+                <a:spcPts val="600"/>
+              </a:spcAft>
+              <a:buFont typeface="Arial" panose="020B0604020202020204" pitchFamily="34" charset="0"/>
+              <a:buChar char="•"/>
+            </a:pPr>
+            <a:r>
+              <a:rPr lang="en-GB" dirty="0"/>
+              <a:t>Filter </a:t>
+            </a:r>
+          </a:p>
+          <a:p>
+            <a:pPr marL="457200" indent="-457200">
+              <a:spcAft>
+                <a:spcPts val="600"/>
+              </a:spcAft>
+              <a:buFont typeface="Arial" panose="020B0604020202020204" pitchFamily="34" charset="0"/>
+              <a:buChar char="•"/>
+            </a:pPr>
+            <a:endParaRPr lang="en-GB" dirty="0"/>
+          </a:p>
+          <a:p>
+            <a:pPr marL="457200" indent="-457200">
+              <a:spcAft>
+                <a:spcPts val="600"/>
+              </a:spcAft>
+              <a:buFont typeface="Arial" panose="020B0604020202020204" pitchFamily="34" charset="0"/>
+              <a:buChar char="•"/>
+            </a:pPr>
+            <a:r>
+              <a:rPr lang="en-GB" dirty="0" err="1"/>
+              <a:t>Shilouette</a:t>
+            </a:r>
+            <a:r>
+              <a:rPr lang="en-GB" dirty="0"/>
+              <a:t> </a:t>
+            </a:r>
+            <a:r>
+              <a:rPr lang="en-GB" dirty="0" err="1"/>
+              <a:t>füllen</a:t>
+            </a:r>
+            <a:endParaRPr lang="en-GB" dirty="0"/>
+          </a:p>
+          <a:p>
+            <a:pPr marL="457200" indent="-457200">
+              <a:spcAft>
+                <a:spcPts val="600"/>
+              </a:spcAft>
+              <a:buFont typeface="Arial" panose="020B0604020202020204" pitchFamily="34" charset="0"/>
+              <a:buChar char="•"/>
+            </a:pPr>
+            <a:endParaRPr lang="en-GB" dirty="0"/>
+          </a:p>
+          <a:p>
+            <a:pPr marL="457200" indent="-457200">
+              <a:spcAft>
+                <a:spcPts val="600"/>
+              </a:spcAft>
+              <a:buFont typeface="Arial" panose="020B0604020202020204" pitchFamily="34" charset="0"/>
+              <a:buChar char="•"/>
+            </a:pPr>
+            <a:r>
+              <a:rPr lang="en-GB" dirty="0" err="1"/>
+              <a:t>Zeitliche</a:t>
+            </a:r>
+            <a:r>
+              <a:rPr lang="en-GB" dirty="0"/>
+              <a:t> </a:t>
+            </a:r>
+            <a:r>
+              <a:rPr lang="en-GB" dirty="0" err="1"/>
+              <a:t>Glättung</a:t>
+            </a:r>
+            <a:endParaRPr lang="en-GB" dirty="0"/>
+          </a:p>
+          <a:p>
+            <a:pPr marL="457200" indent="-457200">
+              <a:spcAft>
+                <a:spcPts val="600"/>
+              </a:spcAft>
+              <a:buFont typeface="Arial" panose="020B0604020202020204" pitchFamily="34" charset="0"/>
+              <a:buChar char="•"/>
+            </a:pPr>
+            <a:endParaRPr lang="en-GB" dirty="0"/>
+          </a:p>
+          <a:p>
+            <a:pPr marL="457200" indent="-457200">
+              <a:spcAft>
+                <a:spcPts val="600"/>
+              </a:spcAft>
+              <a:buFont typeface="Arial" panose="020B0604020202020204" pitchFamily="34" charset="0"/>
+              <a:buChar char="•"/>
+            </a:pPr>
+            <a:r>
+              <a:rPr lang="en-GB" dirty="0" err="1"/>
+              <a:t>Skalierung</a:t>
+            </a:r>
+            <a:r>
+              <a:rPr lang="en-GB" dirty="0"/>
+              <a:t> </a:t>
+            </a:r>
+            <a:endParaRPr lang="de-AT" dirty="0"/>
+          </a:p>
+        </p:txBody>
+      </p:sp>
+      <p:sp>
+        <p:nvSpPr>
+          <p:cNvPr id="4" name="Titel 3">
+            <a:extLst>
+              <a:ext uri="{FF2B5EF4-FFF2-40B4-BE49-F238E27FC236}">
+                <a16:creationId xmlns:a16="http://schemas.microsoft.com/office/drawing/2014/main" id="{9A925EDE-30F7-A95B-3150-54C25647F3EF}"/>
               </a:ext>
             </a:extLst>
           </p:cNvPr>
@@ -30148,51 +33400,315 @@
             <p:ph type="title"/>
           </p:nvPr>
         </p:nvSpPr>
-        <p:spPr/>
+        <p:spPr>
+          <a:xfrm>
+            <a:off x="979488" y="588715"/>
+            <a:ext cx="12312922" cy="780637"/>
+          </a:xfrm>
+        </p:spPr>
         <p:txBody>
-          <a:bodyPr/>
-          <a:lstStyle/>
-          <a:p>
-            <a:pPr rtl="0"/>
-            <a:r>
-              <a:rPr lang="de-AT" dirty="0"/>
-              <a:t>Zusammenfassung</a:t>
-            </a:r>
-          </a:p>
-        </p:txBody>
-      </p:sp>
-      <p:sp>
-        <p:nvSpPr>
-          <p:cNvPr id="4" name="Textplatzhalter 3">
-            <a:extLst>
-              <a:ext uri="{FF2B5EF4-FFF2-40B4-BE49-F238E27FC236}">
-                <a16:creationId xmlns:a16="http://schemas.microsoft.com/office/drawing/2014/main" id="{27794161-D942-764E-0805-D9F4894C1A28}"/>
-              </a:ext>
-            </a:extLst>
-          </p:cNvPr>
-          <p:cNvSpPr>
-            <a:spLocks noGrp="1"/>
-          </p:cNvSpPr>
-          <p:nvPr>
-            <p:ph type="body" sz="quarter" idx="10"/>
-          </p:nvPr>
-        </p:nvSpPr>
-        <p:spPr/>
-        <p:txBody>
-          <a:bodyPr/>
+          <a:bodyPr>
+            <a:normAutofit/>
+          </a:bodyPr>
           <a:lstStyle/>
           <a:p>
             <a:r>
-              <a:rPr lang="de-AT" dirty="0"/>
-              <a:t>….wichtigste 3-4 Punkte</a:t>
+              <a:rPr lang="en-GB" dirty="0"/>
+              <a:t>Main Loop</a:t>
             </a:r>
+            <a:endParaRPr lang="de-AT" dirty="0"/>
           </a:p>
         </p:txBody>
       </p:sp>
     </p:spTree>
     <p:extLst>
       <p:ext uri="{BB962C8B-B14F-4D97-AF65-F5344CB8AC3E}">
-        <p14:creationId xmlns:p14="http://schemas.microsoft.com/office/powerpoint/2010/main" val="3176726208"/>
+        <p14:creationId xmlns:p14="http://schemas.microsoft.com/office/powerpoint/2010/main" val="672960972"/>
+      </p:ext>
+    </p:extLst>
+  </p:cSld>
+  <p:clrMapOvr>
+    <a:masterClrMapping/>
+  </p:clrMapOvr>
+</p:sld>
+</file>
+
+<file path=ppt/slides/slide9.xml><?xml version="1.0" encoding="utf-8"?>
+<p:sld xmlns:a="http://schemas.openxmlformats.org/drawingml/2006/main" xmlns:r="http://schemas.openxmlformats.org/officeDocument/2006/relationships" xmlns:p="http://schemas.openxmlformats.org/presentationml/2006/main">
+  <p:cSld>
+    <p:spTree>
+      <p:nvGrpSpPr>
+        <p:cNvPr id="1" name=""/>
+        <p:cNvGrpSpPr/>
+        <p:nvPr/>
+      </p:nvGrpSpPr>
+      <p:grpSpPr>
+        <a:xfrm>
+          <a:off x="0" y="0"/>
+          <a:ext cx="0" cy="0"/>
+          <a:chOff x="0" y="0"/>
+          <a:chExt cx="0" cy="0"/>
+        </a:xfrm>
+      </p:grpSpPr>
+      <p:pic>
+        <p:nvPicPr>
+          <p:cNvPr id="7" name="Inhaltsplatzhalter 6" descr="Ein Bild, das Rechteck, Muster enthält.&#10;&#10;KI-generierte Inhalte können fehlerhaft sein.">
+            <a:extLst>
+              <a:ext uri="{FF2B5EF4-FFF2-40B4-BE49-F238E27FC236}">
+                <a16:creationId xmlns:a16="http://schemas.microsoft.com/office/drawing/2014/main" id="{D4CF7975-27F8-04F0-CC6A-E1964A6C368C}"/>
+              </a:ext>
+            </a:extLst>
+          </p:cNvPr>
+          <p:cNvPicPr>
+            <a:picLocks noGrp="1" noChangeAspect="1"/>
+          </p:cNvPicPr>
+          <p:nvPr>
+            <p:ph sz="half" idx="3"/>
+          </p:nvPr>
+        </p:nvPicPr>
+        <p:blipFill>
+          <a:blip r:embed="rId2"/>
+          <a:stretch>
+            <a:fillRect/>
+          </a:stretch>
+        </p:blipFill>
+        <p:spPr>
+          <a:xfrm>
+            <a:off x="10375838" y="3310698"/>
+            <a:ext cx="8745283" cy="5859338"/>
+          </a:xfrm>
+          <a:prstGeom prst="rect">
+            <a:avLst/>
+          </a:prstGeom>
+          <a:noFill/>
+          <a:ln>
+            <a:noFill/>
+          </a:ln>
+          <a:effectLst>
+            <a:outerShdw blurRad="292100" dist="139700" dir="2700000" algn="tl" rotWithShape="0">
+              <a:srgbClr val="333333">
+                <a:alpha val="65000"/>
+              </a:srgbClr>
+            </a:outerShdw>
+          </a:effectLst>
+        </p:spPr>
+      </p:pic>
+      <p:sp>
+        <p:nvSpPr>
+          <p:cNvPr id="3" name="Textplatzhalter 2">
+            <a:extLst>
+              <a:ext uri="{FF2B5EF4-FFF2-40B4-BE49-F238E27FC236}">
+                <a16:creationId xmlns:a16="http://schemas.microsoft.com/office/drawing/2014/main" id="{194207CF-239B-5900-A0C7-BE4B995F42D8}"/>
+              </a:ext>
+            </a:extLst>
+          </p:cNvPr>
+          <p:cNvSpPr>
+            <a:spLocks noGrp="1"/>
+          </p:cNvSpPr>
+          <p:nvPr>
+            <p:ph type="body" idx="1"/>
+          </p:nvPr>
+        </p:nvSpPr>
+        <p:spPr>
+          <a:xfrm>
+            <a:off x="979488" y="2460923"/>
+            <a:ext cx="8771002" cy="7560840"/>
+          </a:xfrm>
+        </p:spPr>
+        <p:txBody>
+          <a:bodyPr>
+            <a:normAutofit/>
+          </a:bodyPr>
+          <a:lstStyle/>
+          <a:p>
+            <a:pPr marL="457200" indent="-457200">
+              <a:lnSpc>
+                <a:spcPct val="115000"/>
+              </a:lnSpc>
+              <a:spcAft>
+                <a:spcPts val="600"/>
+              </a:spcAft>
+              <a:buFont typeface="Arial" panose="020B0604020202020204" pitchFamily="34" charset="0"/>
+              <a:buChar char="•"/>
+            </a:pPr>
+            <a:r>
+              <a:rPr lang="en-GB" dirty="0"/>
+              <a:t>U shaped Pins</a:t>
+            </a:r>
+          </a:p>
+          <a:p>
+            <a:pPr marL="457200" indent="-457200">
+              <a:lnSpc>
+                <a:spcPct val="115000"/>
+              </a:lnSpc>
+              <a:spcAft>
+                <a:spcPts val="600"/>
+              </a:spcAft>
+              <a:buFont typeface="Arial" panose="020B0604020202020204" pitchFamily="34" charset="0"/>
+              <a:buChar char="•"/>
+            </a:pPr>
+            <a:r>
+              <a:rPr lang="en-GB" dirty="0" err="1"/>
+              <a:t>Zwischenplatinen</a:t>
+            </a:r>
+            <a:endParaRPr lang="en-GB" dirty="0"/>
+          </a:p>
+          <a:p>
+            <a:pPr>
+              <a:lnSpc>
+                <a:spcPct val="115000"/>
+              </a:lnSpc>
+              <a:spcAft>
+                <a:spcPts val="600"/>
+              </a:spcAft>
+            </a:pPr>
+            <a:r>
+              <a:rPr lang="en-GB" dirty="0"/>
+              <a:t>Problem:</a:t>
+            </a:r>
+          </a:p>
+          <a:p>
+            <a:pPr marL="457200" indent="-457200">
+              <a:lnSpc>
+                <a:spcPct val="115000"/>
+              </a:lnSpc>
+              <a:spcAft>
+                <a:spcPts val="600"/>
+              </a:spcAft>
+              <a:buFont typeface="Arial" panose="020B0604020202020204" pitchFamily="34" charset="0"/>
+              <a:buChar char="•"/>
+            </a:pPr>
+            <a:r>
+              <a:rPr lang="de-AT" dirty="0"/>
+              <a:t>Erste 4 Reihen funktionierten einwandfrei</a:t>
+            </a:r>
+          </a:p>
+          <a:p>
+            <a:pPr marL="457200" indent="-457200">
+              <a:lnSpc>
+                <a:spcPct val="115000"/>
+              </a:lnSpc>
+              <a:spcAft>
+                <a:spcPts val="600"/>
+              </a:spcAft>
+              <a:buFont typeface="Arial" panose="020B0604020202020204" pitchFamily="34" charset="0"/>
+              <a:buChar char="•"/>
+            </a:pPr>
+            <a:r>
+              <a:rPr lang="en-GB" dirty="0"/>
+              <a:t>Data In, </a:t>
+            </a:r>
+            <a:r>
+              <a:rPr lang="en-GB" dirty="0" err="1"/>
+              <a:t>clk</a:t>
+            </a:r>
+            <a:r>
+              <a:rPr lang="en-GB" dirty="0"/>
+              <a:t> </a:t>
+            </a:r>
+            <a:r>
+              <a:rPr lang="en-GB" dirty="0" err="1"/>
+              <a:t>unerkennbar</a:t>
+            </a:r>
+            <a:r>
+              <a:rPr lang="en-GB" dirty="0"/>
+              <a:t> </a:t>
+            </a:r>
+            <a:r>
+              <a:rPr lang="en-GB" dirty="0" err="1"/>
+              <a:t>nach</a:t>
+            </a:r>
+            <a:r>
+              <a:rPr lang="en-GB" dirty="0"/>
+              <a:t> 1 Reihe</a:t>
+            </a:r>
+          </a:p>
+          <a:p>
+            <a:pPr marL="457200" indent="-457200">
+              <a:lnSpc>
+                <a:spcPct val="115000"/>
+              </a:lnSpc>
+              <a:spcAft>
+                <a:spcPts val="600"/>
+              </a:spcAft>
+              <a:buFont typeface="Arial" panose="020B0604020202020204" pitchFamily="34" charset="0"/>
+              <a:buChar char="•"/>
+            </a:pPr>
+            <a:r>
+              <a:rPr lang="en-GB" dirty="0" err="1"/>
+              <a:t>Lösung</a:t>
+            </a:r>
+            <a:r>
+              <a:rPr lang="en-GB" dirty="0"/>
+              <a:t> : OPV-</a:t>
+            </a:r>
+            <a:r>
+              <a:rPr lang="en-GB" dirty="0" err="1"/>
+              <a:t>schmittrigger</a:t>
+            </a:r>
+            <a:r>
+              <a:rPr lang="en-GB" dirty="0"/>
+              <a:t> </a:t>
+            </a:r>
+            <a:r>
+              <a:rPr lang="en-GB" dirty="0" err="1"/>
+              <a:t>Schaltung</a:t>
+            </a:r>
+            <a:endParaRPr lang="en-GB" dirty="0"/>
+          </a:p>
+          <a:p>
+            <a:pPr>
+              <a:lnSpc>
+                <a:spcPct val="115000"/>
+              </a:lnSpc>
+              <a:spcAft>
+                <a:spcPts val="600"/>
+              </a:spcAft>
+            </a:pPr>
+            <a:endParaRPr lang="de-AT" dirty="0"/>
+          </a:p>
+        </p:txBody>
+      </p:sp>
+      <p:sp>
+        <p:nvSpPr>
+          <p:cNvPr id="4" name="Titel 3">
+            <a:extLst>
+              <a:ext uri="{FF2B5EF4-FFF2-40B4-BE49-F238E27FC236}">
+                <a16:creationId xmlns:a16="http://schemas.microsoft.com/office/drawing/2014/main" id="{F29BCFFB-C592-0008-CDD8-80730A301BE2}"/>
+              </a:ext>
+            </a:extLst>
+          </p:cNvPr>
+          <p:cNvSpPr>
+            <a:spLocks noGrp="1"/>
+          </p:cNvSpPr>
+          <p:nvPr>
+            <p:ph type="title"/>
+          </p:nvPr>
+        </p:nvSpPr>
+        <p:spPr>
+          <a:xfrm>
+            <a:off x="979488" y="588715"/>
+            <a:ext cx="12312922" cy="780637"/>
+          </a:xfrm>
+        </p:spPr>
+        <p:txBody>
+          <a:bodyPr>
+            <a:normAutofit/>
+          </a:bodyPr>
+          <a:lstStyle/>
+          <a:p>
+            <a:r>
+              <a:rPr lang="en-GB" dirty="0"/>
+              <a:t>Led Matrix</a:t>
+            </a:r>
+            <a:endParaRPr lang="de-AT" dirty="0"/>
+          </a:p>
+        </p:txBody>
+      </p:sp>
+    </p:spTree>
+    <p:extLst>
+      <p:ext uri="{BB962C8B-B14F-4D97-AF65-F5344CB8AC3E}">
+        <p14:creationId xmlns:p14="http://schemas.microsoft.com/office/powerpoint/2010/main" val="2085217513"/>
       </p:ext>
     </p:extLst>
   </p:cSld>

</xml_diff>